<commit_message>
feat: complete official SIH 2026 presentation with architecture flowcharts and diagrams
</commit_message>
<xml_diff>
--- a/CYBERSHIELD_Architecture_Deck.pptx
+++ b/CYBERSHIELD_Architecture_Deck.pptx
@@ -3108,8 +3108,8 @@
         </p:nvSpPr>
         <p:spPr>
           <a:xfrm>
-            <a:off x="731520" y="731520"/>
-            <a:ext cx="2926080" cy="347472"/>
+            <a:off x="731520" y="640080"/>
+            <a:ext cx="3108960" cy="320040"/>
           </a:xfrm>
           <a:prstGeom prst="roundRect">
             <a:avLst/>
@@ -3162,8 +3162,8 @@
         </p:nvSpPr>
         <p:spPr>
           <a:xfrm>
-            <a:off x="731520" y="1234440"/>
-            <a:ext cx="10698480" cy="1280160"/>
+            <a:off x="731520" y="1051560"/>
+            <a:ext cx="5303520" cy="1371600"/>
           </a:xfrm>
           <a:prstGeom prst="rect">
             <a:avLst/>
@@ -3177,7 +3177,7 @@
           <a:lstStyle/>
           <a:p>
             <a:pPr>
-              <a:defRPr sz="4400" b="1">
+              <a:defRPr sz="4200" b="1">
                 <a:solidFill>
                   <a:srgbClr val="F3F4F6"/>
                 </a:solidFill>
@@ -3189,14 +3189,14 @@
           </a:p>
           <a:p>
             <a:pPr>
-              <a:defRPr sz="2000" b="1">
+              <a:defRPr sz="1800" b="1">
                 <a:solidFill>
                   <a:srgbClr val="00E5FF"/>
                 </a:solidFill>
               </a:defRPr>
             </a:pPr>
             <a:r>
-              <a:t>Unidirectional Threat Detection Engine &amp; Enterprise Web SOC</a:t>
+              <a:t>Unidirectional Threat Detection Engine</a:t>
             </a:r>
           </a:p>
         </p:txBody>
@@ -3209,8 +3209,8 @@
         </p:nvSpPr>
         <p:spPr>
           <a:xfrm>
-            <a:off x="731520" y="2651760"/>
-            <a:ext cx="10698480" cy="640080"/>
+            <a:off x="731520" y="2468880"/>
+            <a:ext cx="5303520" cy="1005840"/>
           </a:xfrm>
           <a:prstGeom prst="rect">
             <a:avLst/>
@@ -3224,7 +3224,7 @@
           <a:lstStyle/>
           <a:p>
             <a:pPr>
-              <a:defRPr sz="1300">
+              <a:defRPr sz="1200">
                 <a:solidFill>
                   <a:srgbClr val="9CA3AF"/>
                 </a:solidFill>
@@ -3244,8 +3244,112 @@
         </p:nvSpPr>
         <p:spPr>
           <a:xfrm>
-            <a:off x="731520" y="3474720"/>
-            <a:ext cx="2542032" cy="2743200"/>
+            <a:off x="6217920" y="731520"/>
+            <a:ext cx="5239512" cy="3108960"/>
+          </a:xfrm>
+          <a:prstGeom prst="roundRect">
+            <a:avLst/>
+          </a:prstGeom>
+          <a:solidFill>
+            <a:srgbClr val="111827"/>
+          </a:solidFill>
+          <a:ln w="15240">
+            <a:solidFill>
+              <a:srgbClr val="00E5FF"/>
+            </a:solidFill>
+          </a:ln>
+        </p:spPr>
+        <p:style>
+          <a:lnRef idx="1">
+            <a:schemeClr val="accent1"/>
+          </a:lnRef>
+          <a:fillRef idx="3">
+            <a:schemeClr val="accent1"/>
+          </a:fillRef>
+          <a:effectRef idx="2">
+            <a:schemeClr val="accent1"/>
+          </a:effectRef>
+          <a:fontRef idx="minor">
+            <a:schemeClr val="lt1"/>
+          </a:fontRef>
+        </p:style>
+        <p:txBody>
+          <a:bodyPr rtlCol="0" anchor="ctr"/>
+          <a:lstStyle/>
+          <a:p>
+            <a:pPr algn="ctr"/>
+          </a:p>
+        </p:txBody>
+      </p:sp>
+      <p:pic>
+        <p:nvPicPr>
+          <p:cNvPr id="6" name="Picture 5" descr="mitre_cyber_center.jpg"/>
+          <p:cNvPicPr>
+            <a:picLocks noChangeAspect="1"/>
+          </p:cNvPicPr>
+          <p:nvPr/>
+        </p:nvPicPr>
+        <p:blipFill>
+          <a:blip r:embed="rId2"/>
+          <a:stretch>
+            <a:fillRect/>
+          </a:stretch>
+        </p:blipFill>
+        <p:spPr>
+          <a:xfrm>
+            <a:off x="6291072" y="804672"/>
+            <a:ext cx="5093208" cy="2788920"/>
+          </a:xfrm>
+          <a:prstGeom prst="rect">
+            <a:avLst/>
+          </a:prstGeom>
+        </p:spPr>
+      </p:pic>
+      <p:sp>
+        <p:nvSpPr>
+          <p:cNvPr id="7" name="TextBox 6"/>
+          <p:cNvSpPr txBox="1"/>
+          <p:nvPr/>
+        </p:nvSpPr>
+        <p:spPr>
+          <a:xfrm>
+            <a:off x="6217920" y="3547872"/>
+            <a:ext cx="5239512" cy="274320"/>
+          </a:xfrm>
+          <a:prstGeom prst="rect">
+            <a:avLst/>
+          </a:prstGeom>
+          <a:noFill/>
+        </p:spPr>
+        <p:txBody>
+          <a:bodyPr wrap="none">
+            <a:spAutoFit/>
+          </a:bodyPr>
+          <a:lstStyle/>
+          <a:p>
+            <a:pPr algn="ctr">
+              <a:defRPr sz="850" b="1">
+                <a:solidFill>
+                  <a:srgbClr val="00E5FF"/>
+                </a:solidFill>
+              </a:defRPr>
+            </a:pPr>
+            <a:r>
+              <a:t>3D HOLOGRAPHIC CYBER DEFENSE OPERATIONS COMMAND ENCLAVE</a:t>
+            </a:r>
+          </a:p>
+        </p:txBody>
+      </p:sp>
+      <p:sp>
+        <p:nvSpPr>
+          <p:cNvPr id="8" name="Rounded Rectangle 7"/>
+          <p:cNvSpPr/>
+          <p:nvPr/>
+        </p:nvSpPr>
+        <p:spPr>
+          <a:xfrm>
+            <a:off x="731520" y="4023360"/>
+            <a:ext cx="2542032" cy="2377440"/>
           </a:xfrm>
           <a:prstGeom prst="roundRect">
             <a:avLst/>
@@ -3283,14 +3387,14 @@
       </p:sp>
       <p:sp>
         <p:nvSpPr>
-          <p:cNvPr id="6" name="TextBox 5"/>
+          <p:cNvPr id="9" name="TextBox 8"/>
           <p:cNvSpPr txBox="1"/>
           <p:nvPr/>
         </p:nvSpPr>
         <p:spPr>
           <a:xfrm>
-            <a:off x="868680" y="3584448"/>
-            <a:ext cx="2267712" cy="2523744"/>
+            <a:off x="859536" y="4114800"/>
+            <a:ext cx="2286000" cy="2194560"/>
           </a:xfrm>
           <a:prstGeom prst="rect">
             <a:avLst/>
@@ -3305,39 +3409,39 @@
           <a:p>
             <a:pPr>
               <a:spcAft>
-                <a:spcPts val="600"/>
-              </a:spcAft>
-              <a:defRPr sz="1400" b="1">
-                <a:solidFill>
-                  <a:srgbClr val="00E5FF"/>
-                </a:solidFill>
-              </a:defRPr>
-            </a:pPr>
-            <a:r>
-              <a:t>OPTICAL DIODE ISOLATION</a:t>
-            </a:r>
-          </a:p>
-          <a:p>
-            <a:pPr>
-              <a:spcAft>
                 <a:spcPts val="400"/>
               </a:spcAft>
-              <a:defRPr sz="1100">
+              <a:defRPr sz="1300" b="1">
+                <a:solidFill>
+                  <a:srgbClr val="00E5FF"/>
+                </a:solidFill>
+              </a:defRPr>
+            </a:pPr>
+            <a:r>
+              <a:t>OPTICAL DIODE ISOLATION</a:t>
+            </a:r>
+          </a:p>
+          <a:p>
+            <a:pPr>
+              <a:spcAft>
+                <a:spcPts val="300"/>
+              </a:spcAft>
+              <a:defRPr sz="1000">
                 <a:solidFill>
                   <a:srgbClr val="F3F4F6"/>
                 </a:solidFill>
               </a:defRPr>
             </a:pPr>
             <a:r>
-              <a:t>• Physical Tx Disabled (Rx = 1)</a:t>
+              <a:t>• Physical Tx severed (Rx = 1)</a:t>
             </a:r>
           </a:p>
           <a:p>
             <a:pPr>
               <a:spcAft>
-                <a:spcPts val="400"/>
+                <a:spcPts val="300"/>
               </a:spcAft>
-              <a:defRPr sz="1100">
+              <a:defRPr sz="1000">
                 <a:solidFill>
                   <a:srgbClr val="F3F4F6"/>
                 </a:solidFill>
@@ -3350,9 +3454,9 @@
           <a:p>
             <a:pPr>
               <a:spcAft>
-                <a:spcPts val="400"/>
+                <a:spcPts val="300"/>
               </a:spcAft>
-              <a:defRPr sz="1100">
+              <a:defRPr sz="1000">
                 <a:solidFill>
                   <a:srgbClr val="F3F4F6"/>
                 </a:solidFill>
@@ -3365,9 +3469,9 @@
           <a:p>
             <a:pPr>
               <a:spcAft>
-                <a:spcPts val="400"/>
+                <a:spcPts val="300"/>
               </a:spcAft>
-              <a:defRPr sz="1100">
+              <a:defRPr sz="1000">
                 <a:solidFill>
                   <a:srgbClr val="F3F4F6"/>
                 </a:solidFill>
@@ -3381,14 +3485,14 @@
       </p:sp>
       <p:sp>
         <p:nvSpPr>
-          <p:cNvPr id="7" name="Rounded Rectangle 6"/>
+          <p:cNvPr id="10" name="Rounded Rectangle 9"/>
           <p:cNvSpPr/>
           <p:nvPr/>
         </p:nvSpPr>
         <p:spPr>
           <a:xfrm>
-            <a:off x="3447288" y="3474720"/>
-            <a:ext cx="2542032" cy="2743200"/>
+            <a:off x="3447288" y="4023360"/>
+            <a:ext cx="2542032" cy="2377440"/>
           </a:xfrm>
           <a:prstGeom prst="roundRect">
             <a:avLst/>
@@ -3426,14 +3530,14 @@
       </p:sp>
       <p:sp>
         <p:nvSpPr>
-          <p:cNvPr id="8" name="TextBox 7"/>
+          <p:cNvPr id="11" name="TextBox 10"/>
           <p:cNvSpPr txBox="1"/>
           <p:nvPr/>
         </p:nvSpPr>
         <p:spPr>
           <a:xfrm>
-            <a:off x="3584448" y="3584448"/>
-            <a:ext cx="2267712" cy="2523744"/>
+            <a:off x="3575304" y="4114800"/>
+            <a:ext cx="2286000" cy="2194560"/>
           </a:xfrm>
           <a:prstGeom prst="rect">
             <a:avLst/>
@@ -3448,24 +3552,24 @@
           <a:p>
             <a:pPr>
               <a:spcAft>
-                <a:spcPts val="600"/>
-              </a:spcAft>
-              <a:defRPr sz="1400" b="1">
-                <a:solidFill>
-                  <a:srgbClr val="3B82F6"/>
-                </a:solidFill>
-              </a:defRPr>
-            </a:pPr>
-            <a:r>
-              <a:t>16-SHARD HASH PARTITIONING</a:t>
-            </a:r>
-          </a:p>
-          <a:p>
-            <a:pPr>
-              <a:spcAft>
                 <a:spcPts val="400"/>
               </a:spcAft>
-              <a:defRPr sz="1100">
+              <a:defRPr sz="1300" b="1">
+                <a:solidFill>
+                  <a:srgbClr val="3B82F6"/>
+                </a:solidFill>
+              </a:defRPr>
+            </a:pPr>
+            <a:r>
+              <a:t>16-SHARD INGRESS</a:t>
+            </a:r>
+          </a:p>
+          <a:p>
+            <a:pPr>
+              <a:spcAft>
+                <a:spcPts val="300"/>
+              </a:spcAft>
+              <a:defRPr sz="1000">
                 <a:solidFill>
                   <a:srgbClr val="F3F4F6"/>
                 </a:solidFill>
@@ -3478,9 +3582,9 @@
           <a:p>
             <a:pPr>
               <a:spcAft>
-                <a:spcPts val="400"/>
+                <a:spcPts val="300"/>
               </a:spcAft>
-              <a:defRPr sz="1100">
+              <a:defRPr sz="1000">
                 <a:solidFill>
                   <a:srgbClr val="F3F4F6"/>
                 </a:solidFill>
@@ -3493,24 +3597,24 @@
           <a:p>
             <a:pPr>
               <a:spcAft>
-                <a:spcPts val="400"/>
+                <a:spcPts val="300"/>
               </a:spcAft>
-              <a:defRPr sz="1100">
+              <a:defRPr sz="1000">
                 <a:solidFill>
                   <a:srgbClr val="F3F4F6"/>
                 </a:solidFill>
               </a:defRPr>
             </a:pPr>
             <a:r>
-              <a:t>• Zero-allocation __slots__ memory</a:t>
+              <a:t>• Zero-allocation __slots__ model</a:t>
             </a:r>
           </a:p>
           <a:p>
             <a:pPr>
               <a:spcAft>
-                <a:spcPts val="400"/>
+                <a:spcPts val="300"/>
               </a:spcAft>
-              <a:defRPr sz="1100">
+              <a:defRPr sz="1000">
                 <a:solidFill>
                   <a:srgbClr val="F3F4F6"/>
                 </a:solidFill>
@@ -3524,14 +3628,14 @@
       </p:sp>
       <p:sp>
         <p:nvSpPr>
-          <p:cNvPr id="9" name="Rounded Rectangle 8"/>
+          <p:cNvPr id="12" name="Rounded Rectangle 11"/>
           <p:cNvSpPr/>
           <p:nvPr/>
         </p:nvSpPr>
         <p:spPr>
           <a:xfrm>
-            <a:off x="6163056" y="3474720"/>
-            <a:ext cx="2542032" cy="2743200"/>
+            <a:off x="6163056" y="4023360"/>
+            <a:ext cx="2542032" cy="2377440"/>
           </a:xfrm>
           <a:prstGeom prst="roundRect">
             <a:avLst/>
@@ -3569,14 +3673,14 @@
       </p:sp>
       <p:sp>
         <p:nvSpPr>
-          <p:cNvPr id="10" name="TextBox 9"/>
+          <p:cNvPr id="13" name="TextBox 12"/>
           <p:cNvSpPr txBox="1"/>
           <p:nvPr/>
         </p:nvSpPr>
         <p:spPr>
           <a:xfrm>
-            <a:off x="6300216" y="3584448"/>
-            <a:ext cx="2267712" cy="2523744"/>
+            <a:off x="6291072" y="4114800"/>
+            <a:ext cx="2286000" cy="2194560"/>
           </a:xfrm>
           <a:prstGeom prst="rect">
             <a:avLst/>
@@ -3591,24 +3695,24 @@
           <a:p>
             <a:pPr>
               <a:spcAft>
-                <a:spcPts val="600"/>
-              </a:spcAft>
-              <a:defRPr sz="1400" b="1">
-                <a:solidFill>
-                  <a:srgbClr val="F59E0B"/>
-                </a:solidFill>
-              </a:defRPr>
-            </a:pPr>
-            <a:r>
-              <a:t>AUTONOMOUS AI &amp; MITRE</a:t>
-            </a:r>
-          </a:p>
-          <a:p>
-            <a:pPr>
-              <a:spcAft>
                 <a:spcPts val="400"/>
               </a:spcAft>
-              <a:defRPr sz="1100">
+              <a:defRPr sz="1300" b="1">
+                <a:solidFill>
+                  <a:srgbClr val="F59E0B"/>
+                </a:solidFill>
+              </a:defRPr>
+            </a:pPr>
+            <a:r>
+              <a:t>AUTONOMOUS AI &amp; MITRE</a:t>
+            </a:r>
+          </a:p>
+          <a:p>
+            <a:pPr>
+              <a:spcAft>
+                <a:spcPts val="300"/>
+              </a:spcAft>
+              <a:defRPr sz="1000">
                 <a:solidFill>
                   <a:srgbClr val="F3F4F6"/>
                 </a:solidFill>
@@ -3621,9 +3725,9 @@
           <a:p>
             <a:pPr>
               <a:spcAft>
-                <a:spcPts val="400"/>
+                <a:spcPts val="300"/>
               </a:spcAft>
-              <a:defRPr sz="1100">
+              <a:defRPr sz="1000">
                 <a:solidFill>
                   <a:srgbClr val="F3F4F6"/>
                 </a:solidFill>
@@ -3636,9 +3740,9 @@
           <a:p>
             <a:pPr>
               <a:spcAft>
-                <a:spcPts val="400"/>
+                <a:spcPts val="300"/>
               </a:spcAft>
-              <a:defRPr sz="1100">
+              <a:defRPr sz="1000">
                 <a:solidFill>
                   <a:srgbClr val="F3F4F6"/>
                 </a:solidFill>
@@ -3651,9 +3755,9 @@
           <a:p>
             <a:pPr>
               <a:spcAft>
-                <a:spcPts val="400"/>
+                <a:spcPts val="300"/>
               </a:spcAft>
-              <a:defRPr sz="1100">
+              <a:defRPr sz="1000">
                 <a:solidFill>
                   <a:srgbClr val="F3F4F6"/>
                 </a:solidFill>
@@ -3667,14 +3771,14 @@
       </p:sp>
       <p:sp>
         <p:nvSpPr>
-          <p:cNvPr id="11" name="Rounded Rectangle 10"/>
+          <p:cNvPr id="14" name="Rounded Rectangle 13"/>
           <p:cNvSpPr/>
           <p:nvPr/>
         </p:nvSpPr>
         <p:spPr>
           <a:xfrm>
-            <a:off x="8878824" y="3474720"/>
-            <a:ext cx="2542032" cy="2743200"/>
+            <a:off x="8878824" y="4023360"/>
+            <a:ext cx="2542032" cy="2377440"/>
           </a:xfrm>
           <a:prstGeom prst="roundRect">
             <a:avLst/>
@@ -3712,14 +3816,14 @@
       </p:sp>
       <p:sp>
         <p:nvSpPr>
-          <p:cNvPr id="12" name="TextBox 11"/>
+          <p:cNvPr id="15" name="TextBox 14"/>
           <p:cNvSpPr txBox="1"/>
           <p:nvPr/>
         </p:nvSpPr>
         <p:spPr>
           <a:xfrm>
-            <a:off x="9015984" y="3584448"/>
-            <a:ext cx="2267712" cy="2523744"/>
+            <a:off x="9006840" y="4114800"/>
+            <a:ext cx="2286000" cy="2194560"/>
           </a:xfrm>
           <a:prstGeom prst="rect">
             <a:avLst/>
@@ -3734,24 +3838,24 @@
           <a:p>
             <a:pPr>
               <a:spcAft>
-                <a:spcPts val="600"/>
-              </a:spcAft>
-              <a:defRPr sz="1400" b="1">
-                <a:solidFill>
-                  <a:srgbClr val="10B981"/>
-                </a:solidFill>
-              </a:defRPr>
-            </a:pPr>
-            <a:r>
-              <a:t>MULTI-PLATFORM SOC</a:t>
-            </a:r>
-          </a:p>
-          <a:p>
-            <a:pPr>
-              <a:spcAft>
                 <a:spcPts val="400"/>
               </a:spcAft>
-              <a:defRPr sz="1100">
+              <a:defRPr sz="1300" b="1">
+                <a:solidFill>
+                  <a:srgbClr val="10B981"/>
+                </a:solidFill>
+              </a:defRPr>
+            </a:pPr>
+            <a:r>
+              <a:t>CROSS-PLATFORM SOC</a:t>
+            </a:r>
+          </a:p>
+          <a:p>
+            <a:pPr>
+              <a:spcAft>
+                <a:spcPts val="300"/>
+              </a:spcAft>
+              <a:defRPr sz="1000">
                 <a:solidFill>
                   <a:srgbClr val="F3F4F6"/>
                 </a:solidFill>
@@ -3764,9 +3868,9 @@
           <a:p>
             <a:pPr>
               <a:spcAft>
-                <a:spcPts val="400"/>
+                <a:spcPts val="300"/>
               </a:spcAft>
-              <a:defRPr sz="1100">
+              <a:defRPr sz="1000">
                 <a:solidFill>
                   <a:srgbClr val="F3F4F6"/>
                 </a:solidFill>
@@ -3779,9 +3883,9 @@
           <a:p>
             <a:pPr>
               <a:spcAft>
-                <a:spcPts val="400"/>
+                <a:spcPts val="300"/>
               </a:spcAft>
-              <a:defRPr sz="1100">
+              <a:defRPr sz="1000">
                 <a:solidFill>
                   <a:srgbClr val="F3F4F6"/>
                 </a:solidFill>
@@ -3794,9 +3898,9 @@
           <a:p>
             <a:pPr>
               <a:spcAft>
-                <a:spcPts val="400"/>
+                <a:spcPts val="300"/>
               </a:spcAft>
-              <a:defRPr sz="1100">
+              <a:defRPr sz="1000">
                 <a:solidFill>
                   <a:srgbClr val="F3F4F6"/>
                 </a:solidFill>
@@ -3843,7 +3947,7 @@
         <p:spPr>
           <a:xfrm>
             <a:off x="731520" y="365760"/>
-            <a:ext cx="4114800" cy="320040"/>
+            <a:ext cx="5029200" cy="292608"/>
           </a:xfrm>
           <a:prstGeom prst="rect">
             <a:avLst/>
@@ -3877,8 +3981,8 @@
         </p:nvSpPr>
         <p:spPr>
           <a:xfrm>
-            <a:off x="731520" y="640080"/>
-            <a:ext cx="10698480" cy="548640"/>
+            <a:off x="731520" y="621792"/>
+            <a:ext cx="10698480" cy="502920"/>
           </a:xfrm>
           <a:prstGeom prst="rect">
             <a:avLst/>
@@ -3892,7 +3996,7 @@
           <a:lstStyle/>
           <a:p>
             <a:pPr>
-              <a:defRPr sz="2200" b="1">
+              <a:defRPr sz="2100" b="1">
                 <a:solidFill>
                   <a:srgbClr val="F3F4F6"/>
                 </a:solidFill>
@@ -3912,8 +4016,8 @@
         </p:nvSpPr>
         <p:spPr>
           <a:xfrm>
-            <a:off x="731520" y="1143000"/>
-            <a:ext cx="10698480" cy="365760"/>
+            <a:off x="731520" y="1097280"/>
+            <a:ext cx="10698480" cy="320040"/>
           </a:xfrm>
           <a:prstGeom prst="rect">
             <a:avLst/>
@@ -3927,7 +4031,7 @@
           <a:lstStyle/>
           <a:p>
             <a:pPr>
-              <a:defRPr sz="1200">
+              <a:defRPr sz="1150">
                 <a:solidFill>
                   <a:srgbClr val="9CA3AF"/>
                 </a:solidFill>
@@ -3947,8 +4051,8 @@
         </p:nvSpPr>
         <p:spPr>
           <a:xfrm>
-            <a:off x="731520" y="1691640"/>
-            <a:ext cx="2011680" cy="1280160"/>
+            <a:off x="731520" y="1508760"/>
+            <a:ext cx="2011680" cy="1143000"/>
           </a:xfrm>
           <a:prstGeom prst="roundRect">
             <a:avLst/>
@@ -3981,7 +4085,7 @@
           <a:lstStyle/>
           <a:p>
             <a:pPr algn="ctr">
-              <a:defRPr sz="1100" b="1">
+              <a:defRPr sz="1000" b="1">
                 <a:solidFill>
                   <a:srgbClr val="00E5FF"/>
                 </a:solidFill>
@@ -3993,22 +4097,22 @@
           </a:p>
           <a:p>
             <a:pPr algn="ctr">
-              <a:defRPr sz="950">
+              <a:defRPr sz="900">
                 <a:solidFill>
                   <a:srgbClr val="F3F4F6"/>
                 </a:solidFill>
               </a:defRPr>
             </a:pPr>
             <a:r>
-              <a:t>Network TAP / SPAN</a:t>
+              <a:t>Mirror TAP / SPAN</a:t>
             </a:r>
             <a:br/>
             <a:r>
-              <a:t>Optical Fiber Diode</a:t>
+              <a:t>Optical Diode Rx</a:t>
             </a:r>
             <a:br/>
             <a:r>
-              <a:t>Tx = 0 / Rx = 1 Only</a:t>
+              <a:t>Tx = 0 Physical Cut</a:t>
             </a:r>
           </a:p>
         </p:txBody>
@@ -4021,8 +4125,8 @@
         </p:nvSpPr>
         <p:spPr>
           <a:xfrm>
-            <a:off x="2779776" y="2194560"/>
-            <a:ext cx="109728" cy="228600"/>
+            <a:off x="2779776" y="1947672"/>
+            <a:ext cx="109728" cy="201168"/>
           </a:xfrm>
           <a:prstGeom prst="rightArrow">
             <a:avLst/>
@@ -4064,8 +4168,8 @@
         </p:nvSpPr>
         <p:spPr>
           <a:xfrm>
-            <a:off x="2926080" y="1691640"/>
-            <a:ext cx="2011680" cy="1280160"/>
+            <a:off x="2926080" y="1508760"/>
+            <a:ext cx="2011680" cy="1143000"/>
           </a:xfrm>
           <a:prstGeom prst="roundRect">
             <a:avLst/>
@@ -4098,7 +4202,7 @@
           <a:lstStyle/>
           <a:p>
             <a:pPr algn="ctr">
-              <a:defRPr sz="1100" b="1">
+              <a:defRPr sz="1000" b="1">
                 <a:solidFill>
                   <a:srgbClr val="3B82F6"/>
                 </a:solidFill>
@@ -4110,7 +4214,7 @@
           </a:p>
           <a:p>
             <a:pPr algn="ctr">
-              <a:defRPr sz="950">
+              <a:defRPr sz="900">
                 <a:solidFill>
                   <a:srgbClr val="F3F4F6"/>
                 </a:solidFill>
@@ -4121,7 +4225,7 @@
             </a:r>
             <a:br/>
             <a:r>
-              <a:t>IPv4 / IPv6 Header</a:t>
+              <a:t>IPv4 / IPv6 Wire Decode</a:t>
             </a:r>
             <a:br/>
             <a:r>
@@ -4138,8 +4242,8 @@
         </p:nvSpPr>
         <p:spPr>
           <a:xfrm>
-            <a:off x="4974336" y="2194560"/>
-            <a:ext cx="109728" cy="228600"/>
+            <a:off x="4974336" y="1947672"/>
+            <a:ext cx="109728" cy="201168"/>
           </a:xfrm>
           <a:prstGeom prst="rightArrow">
             <a:avLst/>
@@ -4181,8 +4285,8 @@
         </p:nvSpPr>
         <p:spPr>
           <a:xfrm>
-            <a:off x="5120640" y="1691640"/>
-            <a:ext cx="2011680" cy="1280160"/>
+            <a:off x="5120640" y="1508760"/>
+            <a:ext cx="2011680" cy="1143000"/>
           </a:xfrm>
           <a:prstGeom prst="roundRect">
             <a:avLst/>
@@ -4215,19 +4319,19 @@
           <a:lstStyle/>
           <a:p>
             <a:pPr algn="ctr">
-              <a:defRPr sz="1100" b="1">
+              <a:defRPr sz="1000" b="1">
                 <a:solidFill>
                   <a:srgbClr val="F59E0B"/>
                 </a:solidFill>
               </a:defRPr>
             </a:pPr>
             <a:r>
-              <a:t>3. MICRO-BATCHING</a:t>
+              <a:t>3. MICRO-BATCHER</a:t>
             </a:r>
           </a:p>
           <a:p>
             <a:pPr algn="ctr">
-              <a:defRPr sz="950">
+              <a:defRPr sz="900">
                 <a:solidFill>
                   <a:srgbClr val="F3F4F6"/>
                 </a:solidFill>
@@ -4255,8 +4359,8 @@
         </p:nvSpPr>
         <p:spPr>
           <a:xfrm>
-            <a:off x="7168896" y="2194560"/>
-            <a:ext cx="109728" cy="228600"/>
+            <a:off x="7168896" y="1947672"/>
+            <a:ext cx="109728" cy="201168"/>
           </a:xfrm>
           <a:prstGeom prst="rightArrow">
             <a:avLst/>
@@ -4298,8 +4402,8 @@
         </p:nvSpPr>
         <p:spPr>
           <a:xfrm>
-            <a:off x="7315200" y="1691640"/>
-            <a:ext cx="2011680" cy="1280160"/>
+            <a:off x="7315200" y="1508760"/>
+            <a:ext cx="2011680" cy="1143000"/>
           </a:xfrm>
           <a:prstGeom prst="roundRect">
             <a:avLst/>
@@ -4332,7 +4436,7 @@
           <a:lstStyle/>
           <a:p>
             <a:pPr algn="ctr">
-              <a:defRPr sz="1100" b="1">
+              <a:defRPr sz="1000" b="1">
                 <a:solidFill>
                   <a:srgbClr val="00E5FF"/>
                 </a:solidFill>
@@ -4344,7 +4448,7 @@
           </a:p>
           <a:p>
             <a:pPr algn="ctr">
-              <a:defRPr sz="950">
+              <a:defRPr sz="900">
                 <a:solidFill>
                   <a:srgbClr val="F3F4F6"/>
                 </a:solidFill>
@@ -4372,8 +4476,8 @@
         </p:nvSpPr>
         <p:spPr>
           <a:xfrm>
-            <a:off x="9363456" y="2194560"/>
-            <a:ext cx="109728" cy="228600"/>
+            <a:off x="9363456" y="1947672"/>
+            <a:ext cx="109728" cy="201168"/>
           </a:xfrm>
           <a:prstGeom prst="rightArrow">
             <a:avLst/>
@@ -4415,8 +4519,8 @@
         </p:nvSpPr>
         <p:spPr>
           <a:xfrm>
-            <a:off x="9509760" y="1691640"/>
-            <a:ext cx="2011680" cy="1280160"/>
+            <a:off x="9509760" y="1508760"/>
+            <a:ext cx="2011680" cy="1143000"/>
           </a:xfrm>
           <a:prstGeom prst="roundRect">
             <a:avLst/>
@@ -4449,7 +4553,7 @@
           <a:lstStyle/>
           <a:p>
             <a:pPr algn="ctr">
-              <a:defRPr sz="1100" b="1">
+              <a:defRPr sz="1000" b="1">
                 <a:solidFill>
                   <a:srgbClr val="10B981"/>
                 </a:solidFill>
@@ -4461,7 +4565,7 @@
           </a:p>
           <a:p>
             <a:pPr algn="ctr">
-              <a:defRPr sz="950">
+              <a:defRPr sz="900">
                 <a:solidFill>
                   <a:srgbClr val="F3F4F6"/>
                 </a:solidFill>
@@ -4476,7 +4580,7 @@
             </a:r>
             <a:br/>
             <a:r>
-              <a:t>Sub-110ms Triage Loop</a:t>
+              <a:t>Sub-110ms Triage SLA</a:t>
             </a:r>
           </a:p>
         </p:txBody>
@@ -4489,8 +4593,112 @@
         </p:nvSpPr>
         <p:spPr>
           <a:xfrm>
-            <a:off x="731520" y="3246120"/>
-            <a:ext cx="3429000" cy="3108960"/>
+            <a:off x="731520" y="2834640"/>
+            <a:ext cx="5230368" cy="3566160"/>
+          </a:xfrm>
+          <a:prstGeom prst="roundRect">
+            <a:avLst/>
+          </a:prstGeom>
+          <a:solidFill>
+            <a:srgbClr val="111827"/>
+          </a:solidFill>
+          <a:ln w="15240">
+            <a:solidFill>
+              <a:srgbClr val="00E5FF"/>
+            </a:solidFill>
+          </a:ln>
+        </p:spPr>
+        <p:style>
+          <a:lnRef idx="1">
+            <a:schemeClr val="accent1"/>
+          </a:lnRef>
+          <a:fillRef idx="3">
+            <a:schemeClr val="accent1"/>
+          </a:fillRef>
+          <a:effectRef idx="2">
+            <a:schemeClr val="accent1"/>
+          </a:effectRef>
+          <a:fontRef idx="minor">
+            <a:schemeClr val="lt1"/>
+          </a:fontRef>
+        </p:style>
+        <p:txBody>
+          <a:bodyPr rtlCol="0" anchor="ctr"/>
+          <a:lstStyle/>
+          <a:p>
+            <a:pPr algn="ctr"/>
+          </a:p>
+        </p:txBody>
+      </p:sp>
+      <p:pic>
+        <p:nvPicPr>
+          <p:cNvPr id="15" name="Picture 14" descr="data_diode_hardware.jpg"/>
+          <p:cNvPicPr>
+            <a:picLocks noChangeAspect="1"/>
+          </p:cNvPicPr>
+          <p:nvPr/>
+        </p:nvPicPr>
+        <p:blipFill>
+          <a:blip r:embed="rId2"/>
+          <a:stretch>
+            <a:fillRect/>
+          </a:stretch>
+        </p:blipFill>
+        <p:spPr>
+          <a:xfrm>
+            <a:off x="804672" y="2907792"/>
+            <a:ext cx="5084064" cy="3246120"/>
+          </a:xfrm>
+          <a:prstGeom prst="rect">
+            <a:avLst/>
+          </a:prstGeom>
+        </p:spPr>
+      </p:pic>
+      <p:sp>
+        <p:nvSpPr>
+          <p:cNvPr id="16" name="TextBox 15"/>
+          <p:cNvSpPr txBox="1"/>
+          <p:nvPr/>
+        </p:nvSpPr>
+        <p:spPr>
+          <a:xfrm>
+            <a:off x="731520" y="6108192"/>
+            <a:ext cx="5230368" cy="274320"/>
+          </a:xfrm>
+          <a:prstGeom prst="rect">
+            <a:avLst/>
+          </a:prstGeom>
+          <a:noFill/>
+        </p:spPr>
+        <p:txBody>
+          <a:bodyPr wrap="none">
+            <a:spAutoFit/>
+          </a:bodyPr>
+          <a:lstStyle/>
+          <a:p>
+            <a:pPr algn="ctr">
+              <a:defRPr sz="850" b="1">
+                <a:solidFill>
+                  <a:srgbClr val="00E5FF"/>
+                </a:solidFill>
+              </a:defRPr>
+            </a:pPr>
+            <a:r>
+              <a:t>PHYSICAL OPTICAL DATA DIODE NETWORK TAP (TX SEVERED / RX LISTEN-ONLY)</a:t>
+            </a:r>
+          </a:p>
+        </p:txBody>
+      </p:sp>
+      <p:sp>
+        <p:nvSpPr>
+          <p:cNvPr id="17" name="Rounded Rectangle 16"/>
+          <p:cNvSpPr/>
+          <p:nvPr/>
+        </p:nvSpPr>
+        <p:spPr>
+          <a:xfrm>
+            <a:off x="6217920" y="2834640"/>
+            <a:ext cx="5239512" cy="1691640"/>
           </a:xfrm>
           <a:prstGeom prst="roundRect">
             <a:avLst/>
@@ -4528,14 +4736,14 @@
       </p:sp>
       <p:sp>
         <p:nvSpPr>
-          <p:cNvPr id="15" name="TextBox 14"/>
+          <p:cNvPr id="18" name="TextBox 17"/>
           <p:cNvSpPr txBox="1"/>
           <p:nvPr/>
         </p:nvSpPr>
         <p:spPr>
           <a:xfrm>
-            <a:off x="868680" y="3355848"/>
-            <a:ext cx="3154680" cy="2889504"/>
+            <a:off x="6345936" y="2926080"/>
+            <a:ext cx="4983480" cy="1508760"/>
           </a:xfrm>
           <a:prstGeom prst="rect">
             <a:avLst/>
@@ -4550,24 +4758,24 @@
           <a:p>
             <a:pPr>
               <a:spcAft>
-                <a:spcPts val="600"/>
-              </a:spcAft>
-              <a:defRPr sz="1400" b="1">
-                <a:solidFill>
-                  <a:srgbClr val="00E5FF"/>
-                </a:solidFill>
-              </a:defRPr>
-            </a:pPr>
-            <a:r>
-              <a:t>ZERO-CONTENTION CONCURRENCY</a:t>
-            </a:r>
-          </a:p>
-          <a:p>
-            <a:pPr>
-              <a:spcAft>
                 <a:spcPts val="400"/>
               </a:spcAft>
-              <a:defRPr sz="1100">
+              <a:defRPr sz="1300" b="1">
+                <a:solidFill>
+                  <a:srgbClr val="00E5FF"/>
+                </a:solidFill>
+              </a:defRPr>
+            </a:pPr>
+            <a:r>
+              <a:t>ZERO-CONTENTION CONCURRENCY</a:t>
+            </a:r>
+          </a:p>
+          <a:p>
+            <a:pPr>
+              <a:spcAft>
+                <a:spcPts val="300"/>
+              </a:spcAft>
+              <a:defRPr sz="1000">
                 <a:solidFill>
                   <a:srgbClr val="F3F4F6"/>
                 </a:solidFill>
@@ -4580,45 +4788,45 @@
           <a:p>
             <a:pPr>
               <a:spcAft>
-                <a:spcPts val="400"/>
+                <a:spcPts val="300"/>
               </a:spcAft>
-              <a:defRPr sz="1100">
+              <a:defRPr sz="1000">
                 <a:solidFill>
                   <a:srgbClr val="F3F4F6"/>
                 </a:solidFill>
               </a:defRPr>
             </a:pPr>
             <a:r>
-              <a:t>• Lock Amortization: Groups micro-batches by target shard prior to acquisition, reducing lock requests from O(B) to O(16).</a:t>
+              <a:t>• Lock Amortization: Groups micro-batches by target shard prior to lock acquisition.</a:t>
             </a:r>
           </a:p>
           <a:p>
             <a:pPr>
               <a:spcAft>
-                <a:spcPts val="400"/>
+                <a:spcPts val="300"/>
               </a:spcAft>
-              <a:defRPr sz="1100">
+              <a:defRPr sz="1000">
                 <a:solidFill>
                   <a:srgbClr val="F3F4F6"/>
                 </a:solidFill>
               </a:defRPr>
             </a:pPr>
             <a:r>
-              <a:t>• Benchmarked Throughput: Sustained 25,000–50,000+ pps on commodity CPU cores without dropped frames.</a:t>
-            </a:r>
-          </a:p>
-        </p:txBody>
-      </p:sp>
-      <p:sp>
-        <p:nvSpPr>
-          <p:cNvPr id="16" name="Rounded Rectangle 15"/>
+              <a:t>• Throughput: Sustained 25,000–50,000+ pps on commodity CPU cores without frame drops.</a:t>
+            </a:r>
+          </a:p>
+        </p:txBody>
+      </p:sp>
+      <p:sp>
+        <p:nvSpPr>
+          <p:cNvPr id="19" name="Rounded Rectangle 18"/>
           <p:cNvSpPr/>
           <p:nvPr/>
         </p:nvSpPr>
         <p:spPr>
           <a:xfrm>
-            <a:off x="4370832" y="3246120"/>
-            <a:ext cx="3429000" cy="3108960"/>
+            <a:off x="6217920" y="4709160"/>
+            <a:ext cx="5239512" cy="1691640"/>
           </a:xfrm>
           <a:prstGeom prst="roundRect">
             <a:avLst/>
@@ -4656,14 +4864,14 @@
       </p:sp>
       <p:sp>
         <p:nvSpPr>
-          <p:cNvPr id="17" name="TextBox 16"/>
+          <p:cNvPr id="20" name="TextBox 19"/>
           <p:cNvSpPr txBox="1"/>
           <p:nvPr/>
         </p:nvSpPr>
         <p:spPr>
           <a:xfrm>
-            <a:off x="4507992" y="3355848"/>
-            <a:ext cx="3154680" cy="2889504"/>
+            <a:off x="6345936" y="4800600"/>
+            <a:ext cx="4983480" cy="1508760"/>
           </a:xfrm>
           <a:prstGeom prst="rect">
             <a:avLst/>
@@ -4678,189 +4886,61 @@
           <a:p>
             <a:pPr>
               <a:spcAft>
-                <a:spcPts val="600"/>
-              </a:spcAft>
-              <a:defRPr sz="1400" b="1">
-                <a:solidFill>
-                  <a:srgbClr val="3B82F6"/>
-                </a:solidFill>
-              </a:defRPr>
-            </a:pPr>
-            <a:r>
-              <a:t>LOW-ALLOCATION MEMORY MODEL</a:t>
-            </a:r>
-          </a:p>
-          <a:p>
-            <a:pPr>
-              <a:spcAft>
                 <a:spcPts val="400"/>
               </a:spcAft>
-              <a:defRPr sz="1100">
+              <a:defRPr sz="1300" b="1">
+                <a:solidFill>
+                  <a:srgbClr val="10B981"/>
+                </a:solidFill>
+              </a:defRPr>
+            </a:pPr>
+            <a:r>
+              <a:t>LOW-ALLOCATION MEMORY &amp; STEALTH</a:t>
+            </a:r>
+          </a:p>
+          <a:p>
+            <a:pPr>
+              <a:spcAft>
+                <a:spcPts val="300"/>
+              </a:spcAft>
+              <a:defRPr sz="1000">
                 <a:solidFill>
                   <a:srgbClr val="F3F4F6"/>
                 </a:solidFill>
               </a:defRPr>
             </a:pPr>
             <a:r>
-              <a:t>• Python __slots__ Optimization: Structs PacketMetadata and ThreatAlert eliminate dynamic dictionary overhead.</a:t>
+              <a:t>• Python __slots__ Optimization: Eliminates dynamic dictionary allocation overhead.</a:t>
             </a:r>
           </a:p>
           <a:p>
             <a:pPr>
               <a:spcAft>
-                <a:spcPts val="400"/>
+                <a:spcPts val="300"/>
               </a:spcAft>
-              <a:defRPr sz="1100">
+              <a:defRPr sz="1000">
                 <a:solidFill>
                   <a:srgbClr val="F3F4F6"/>
                 </a:solidFill>
               </a:defRPr>
             </a:pPr>
             <a:r>
-              <a:t>• Bounded Deques: In-memory sliding windows (maxlen=250) prevent memory leaks under multi-million packet surges.</a:t>
+              <a:t>• Bounded Ring Buffers: In-memory sliding windows prevent memory leaks under surges.</a:t>
             </a:r>
           </a:p>
           <a:p>
             <a:pPr>
               <a:spcAft>
-                <a:spcPts val="400"/>
+                <a:spcPts val="300"/>
               </a:spcAft>
-              <a:defRPr sz="1100">
+              <a:defRPr sz="1000">
                 <a:solidFill>
                   <a:srgbClr val="F3F4F6"/>
                 </a:solidFill>
               </a:defRPr>
             </a:pPr>
             <a:r>
-              <a:t>• Zero Garbage Collection Spikes: Predictable sub-millisecond execution SLAs.</a:t>
-            </a:r>
-          </a:p>
-        </p:txBody>
-      </p:sp>
-      <p:sp>
-        <p:nvSpPr>
-          <p:cNvPr id="18" name="Rounded Rectangle 17"/>
-          <p:cNvSpPr/>
-          <p:nvPr/>
-        </p:nvSpPr>
-        <p:spPr>
-          <a:xfrm>
-            <a:off x="8010144" y="3246120"/>
-            <a:ext cx="3429000" cy="3108960"/>
-          </a:xfrm>
-          <a:prstGeom prst="roundRect">
-            <a:avLst/>
-          </a:prstGeom>
-          <a:solidFill>
-            <a:srgbClr val="172135"/>
-          </a:solidFill>
-          <a:ln w="15240">
-            <a:solidFill>
-              <a:srgbClr val="25324E"/>
-            </a:solidFill>
-          </a:ln>
-        </p:spPr>
-        <p:style>
-          <a:lnRef idx="1">
-            <a:schemeClr val="accent1"/>
-          </a:lnRef>
-          <a:fillRef idx="3">
-            <a:schemeClr val="accent1"/>
-          </a:fillRef>
-          <a:effectRef idx="2">
-            <a:schemeClr val="accent1"/>
-          </a:effectRef>
-          <a:fontRef idx="minor">
-            <a:schemeClr val="lt1"/>
-          </a:fontRef>
-        </p:style>
-        <p:txBody>
-          <a:bodyPr rtlCol="0" anchor="ctr"/>
-          <a:lstStyle/>
-          <a:p>
-            <a:pPr algn="ctr"/>
-          </a:p>
-        </p:txBody>
-      </p:sp>
-      <p:sp>
-        <p:nvSpPr>
-          <p:cNvPr id="19" name="TextBox 18"/>
-          <p:cNvSpPr txBox="1"/>
-          <p:nvPr/>
-        </p:nvSpPr>
-        <p:spPr>
-          <a:xfrm>
-            <a:off x="8147304" y="3355848"/>
-            <a:ext cx="3154680" cy="2889504"/>
-          </a:xfrm>
-          <a:prstGeom prst="rect">
-            <a:avLst/>
-          </a:prstGeom>
-          <a:noFill/>
-        </p:spPr>
-        <p:txBody>
-          <a:bodyPr wrap="square">
-            <a:spAutoFit/>
-          </a:bodyPr>
-          <a:lstStyle/>
-          <a:p>
-            <a:pPr>
-              <a:spcAft>
-                <a:spcPts val="600"/>
-              </a:spcAft>
-              <a:defRPr sz="1400" b="1">
-                <a:solidFill>
-                  <a:srgbClr val="10B981"/>
-                </a:solidFill>
-              </a:defRPr>
-            </a:pPr>
-            <a:r>
-              <a:t>UNIDIRECTIONAL DIODE GUARANTEE</a:t>
-            </a:r>
-          </a:p>
-          <a:p>
-            <a:pPr>
-              <a:spcAft>
-                <a:spcPts val="400"/>
-              </a:spcAft>
-              <a:defRPr sz="1100">
-                <a:solidFill>
-                  <a:srgbClr val="F3F4F6"/>
-                </a:solidFill>
-              </a:defRPr>
-            </a:pPr>
-            <a:r>
-              <a:t>• Physical Optical TAP: Monitored interface laser transmitter physically cut; receive fiber strictly isolated.</a:t>
-            </a:r>
-          </a:p>
-          <a:p>
-            <a:pPr>
-              <a:spcAft>
-                <a:spcPts val="400"/>
-              </a:spcAft>
-              <a:defRPr sz="1100">
-                <a:solidFill>
-                  <a:srgbClr val="F3F4F6"/>
-                </a:solidFill>
-              </a:defRPr>
-            </a:pPr>
-            <a:r>
-              <a:t>• Passive Packet Dissection: Zero TCP RST or ICMP responses emitted back onto the customer network.</a:t>
-            </a:r>
-          </a:p>
-          <a:p>
-            <a:pPr>
-              <a:spcAft>
-                <a:spcPts val="400"/>
-              </a:spcAft>
-              <a:defRPr sz="1100">
-                <a:solidFill>
-                  <a:srgbClr val="F3F4F6"/>
-                </a:solidFill>
-              </a:defRPr>
-            </a:pPr>
-            <a:r>
-              <a:t>• Complete Stealth: Adversaries cannot detect or target the monitoring sensor enclave.</a:t>
+              <a:t>• Passive Stealth: Zero TCP RST or ICMP packets emitted back onto monitored wire.</a:t>
             </a:r>
           </a:p>
         </p:txBody>
@@ -4900,7 +4980,7 @@
         <p:spPr>
           <a:xfrm>
             <a:off x="731520" y="365760"/>
-            <a:ext cx="4114800" cy="320040"/>
+            <a:ext cx="5029200" cy="292608"/>
           </a:xfrm>
           <a:prstGeom prst="rect">
             <a:avLst/>
@@ -4934,8 +5014,8 @@
         </p:nvSpPr>
         <p:spPr>
           <a:xfrm>
-            <a:off x="731520" y="640080"/>
-            <a:ext cx="10698480" cy="548640"/>
+            <a:off x="731520" y="621792"/>
+            <a:ext cx="10698480" cy="502920"/>
           </a:xfrm>
           <a:prstGeom prst="rect">
             <a:avLst/>
@@ -4949,14 +5029,14 @@
           <a:lstStyle/>
           <a:p>
             <a:pPr>
-              <a:defRPr sz="2200" b="1">
+              <a:defRPr sz="2100" b="1">
                 <a:solidFill>
                   <a:srgbClr val="F3F4F6"/>
                 </a:solidFill>
               </a:defRPr>
             </a:pPr>
             <a:r>
-              <a:t>Algorithmic Threat Detection: Statistical, Entropy &amp; Fingerprinting</a:t>
+              <a:t>Mathematical Threat Detection: AI/ML, Entropy &amp; JA4 Fingerprinting</a:t>
             </a:r>
           </a:p>
         </p:txBody>
@@ -4969,8 +5049,8 @@
         </p:nvSpPr>
         <p:spPr>
           <a:xfrm>
-            <a:off x="731520" y="1143000"/>
-            <a:ext cx="10698480" cy="365760"/>
+            <a:off x="731520" y="1097280"/>
+            <a:ext cx="10698480" cy="320040"/>
           </a:xfrm>
           <a:prstGeom prst="rect">
             <a:avLst/>
@@ -4984,14 +5064,14 @@
           <a:lstStyle/>
           <a:p>
             <a:pPr>
-              <a:defRPr sz="1200">
+              <a:defRPr sz="1150">
                 <a:solidFill>
                   <a:srgbClr val="9CA3AF"/>
                 </a:solidFill>
               </a:defRPr>
             </a:pPr>
             <a:r>
-              <a:t>Deterministic models operating in parallel across sliding windows for precision threat attribution.</a:t>
+              <a:t>Deterministic models operating concurrently across sliding windows for precision threat attribution.</a:t>
             </a:r>
           </a:p>
         </p:txBody>
@@ -5004,8 +5084,8 @@
         </p:nvSpPr>
         <p:spPr>
           <a:xfrm>
-            <a:off x="731520" y="1645920"/>
-            <a:ext cx="5230368" cy="2331720"/>
+            <a:off x="731520" y="1508760"/>
+            <a:ext cx="5230368" cy="2423160"/>
           </a:xfrm>
           <a:prstGeom prst="roundRect">
             <a:avLst/>
@@ -5049,8 +5129,8 @@
         </p:nvSpPr>
         <p:spPr>
           <a:xfrm>
-            <a:off x="868680" y="1755648"/>
-            <a:ext cx="4956048" cy="2112264"/>
+            <a:off x="859536" y="1600200"/>
+            <a:ext cx="4974336" cy="2240280"/>
           </a:xfrm>
           <a:prstGeom prst="rect">
             <a:avLst/>
@@ -5065,24 +5145,24 @@
           <a:p>
             <a:pPr>
               <a:spcAft>
-                <a:spcPts val="600"/>
-              </a:spcAft>
-              <a:defRPr sz="1400" b="1">
-                <a:solidFill>
-                  <a:srgbClr val="F59E0B"/>
-                </a:solidFill>
-              </a:defRPr>
-            </a:pPr>
-            <a:r>
-              <a:t>1. BOTNET C2 BEACONING (INTER-ARRIVAL TIME &amp; CV)</a:t>
-            </a:r>
-          </a:p>
-          <a:p>
-            <a:pPr>
-              <a:spcAft>
                 <a:spcPts val="400"/>
               </a:spcAft>
-              <a:defRPr sz="1100">
+              <a:defRPr sz="1300" b="1">
+                <a:solidFill>
+                  <a:srgbClr val="F59E0B"/>
+                </a:solidFill>
+              </a:defRPr>
+            </a:pPr>
+            <a:r>
+              <a:t>1. BOTNET C2 BEACONING (IAT &amp; CV)</a:t>
+            </a:r>
+          </a:p>
+          <a:p>
+            <a:pPr>
+              <a:spcAft>
+                <a:spcPts val="300"/>
+              </a:spcAft>
+              <a:defRPr sz="1000">
                 <a:solidFill>
                   <a:srgbClr val="F3F4F6"/>
                 </a:solidFill>
@@ -5095,39 +5175,39 @@
           <a:p>
             <a:pPr>
               <a:spcAft>
-                <a:spcPts val="400"/>
+                <a:spcPts val="300"/>
               </a:spcAft>
-              <a:defRPr sz="1100">
+              <a:defRPr sz="1000">
                 <a:solidFill>
                   <a:srgbClr val="F3F4F6"/>
                 </a:solidFill>
               </a:defRPr>
             </a:pPr>
             <a:r>
-              <a:t>• Formula: CV = σ / μ  (where μ = mean interval, σ = standard deviation of arrival deltas).</a:t>
+              <a:t>• Formula: CV = σ / μ  (where μ = mean interval, σ = standard deviation of deltas).</a:t>
             </a:r>
           </a:p>
           <a:p>
             <a:pPr>
               <a:spcAft>
-                <a:spcPts val="400"/>
+                <a:spcPts val="300"/>
               </a:spcAft>
-              <a:defRPr sz="1100">
+              <a:defRPr sz="1000">
                 <a:solidFill>
                   <a:srgbClr val="F3F4F6"/>
                 </a:solidFill>
               </a:defRPr>
             </a:pPr>
             <a:r>
-              <a:t>• Detection Threshold: CV &lt; 0.15 indicates automated heartbeat periodicity (Cobalt Strike / Sliver).</a:t>
+              <a:t>• Detection Boundary: CV &lt; 0.15 identifies automated heartbeat periodicity.</a:t>
             </a:r>
           </a:p>
           <a:p>
             <a:pPr>
               <a:spcAft>
-                <a:spcPts val="400"/>
+                <a:spcPts val="300"/>
               </a:spcAft>
-              <a:defRPr sz="1100">
+              <a:defRPr sz="1000">
                 <a:solidFill>
                   <a:srgbClr val="F3F4F6"/>
                 </a:solidFill>
@@ -5147,8 +5227,8 @@
         </p:nvSpPr>
         <p:spPr>
           <a:xfrm>
-            <a:off x="6217920" y="1645920"/>
-            <a:ext cx="5230368" cy="2331720"/>
+            <a:off x="731520" y="4069080"/>
+            <a:ext cx="5230368" cy="2423160"/>
           </a:xfrm>
           <a:prstGeom prst="roundRect">
             <a:avLst/>
@@ -5192,8 +5272,8 @@
         </p:nvSpPr>
         <p:spPr>
           <a:xfrm>
-            <a:off x="6355080" y="1755648"/>
-            <a:ext cx="4956048" cy="2112264"/>
+            <a:off x="859536" y="4160520"/>
+            <a:ext cx="4974336" cy="2240280"/>
           </a:xfrm>
           <a:prstGeom prst="rect">
             <a:avLst/>
@@ -5208,39 +5288,39 @@
           <a:p>
             <a:pPr>
               <a:spcAft>
-                <a:spcPts val="600"/>
-              </a:spcAft>
-              <a:defRPr sz="1400" b="1">
-                <a:solidFill>
-                  <a:srgbClr val="FF4757"/>
-                </a:solidFill>
-              </a:defRPr>
-            </a:pPr>
-            <a:r>
-              <a:t>2. DNS TUNNELING &amp; DGA EXFILTRATION (SHANNON ENTROPY)</a:t>
-            </a:r>
-          </a:p>
-          <a:p>
-            <a:pPr>
-              <a:spcAft>
                 <a:spcPts val="400"/>
               </a:spcAft>
-              <a:defRPr sz="1100">
+              <a:defRPr sz="1300" b="1">
+                <a:solidFill>
+                  <a:srgbClr val="FF4757"/>
+                </a:solidFill>
+              </a:defRPr>
+            </a:pPr>
+            <a:r>
+              <a:t>2. DNS TUNNELING &amp; DGA (FAST SHANNON ENTROPY)</a:t>
+            </a:r>
+          </a:p>
+          <a:p>
+            <a:pPr>
+              <a:spcAft>
+                <a:spcPts val="300"/>
+              </a:spcAft>
+              <a:defRPr sz="1000">
                 <a:solidFill>
                   <a:srgbClr val="F3F4F6"/>
                 </a:solidFill>
               </a:defRPr>
             </a:pPr>
             <a:r>
-              <a:t>• Theory: Base32/64 exfiltration and algorithmically generated domains exhibit high entropy.</a:t>
+              <a:t>• Theory: Base32/64 exfiltration payloads pack high information density into subdomains.</a:t>
             </a:r>
           </a:p>
           <a:p>
             <a:pPr>
               <a:spcAft>
-                <a:spcPts val="400"/>
+                <a:spcPts val="300"/>
               </a:spcAft>
-              <a:defRPr sz="1100">
+              <a:defRPr sz="1000">
                 <a:solidFill>
                   <a:srgbClr val="F3F4F6"/>
                 </a:solidFill>
@@ -5253,31 +5333,31 @@
           <a:p>
             <a:pPr>
               <a:spcAft>
-                <a:spcPts val="400"/>
+                <a:spcPts val="300"/>
               </a:spcAft>
-              <a:defRPr sz="1100">
+              <a:defRPr sz="1000">
                 <a:solidFill>
                   <a:srgbClr val="F3F4F6"/>
                 </a:solidFill>
               </a:defRPr>
             </a:pPr>
             <a:r>
-              <a:t>• Hardware Acceleration: Accelerated via pre-computed _LOG2_CACHE[k] lookup table (O(N)).</a:t>
+              <a:t>• Table Cache: Accelerated via pre-computed _LOG2_CACHE[k] lookup table in O(N).</a:t>
             </a:r>
           </a:p>
           <a:p>
             <a:pPr>
               <a:spcAft>
-                <a:spcPts val="400"/>
+                <a:spcPts val="300"/>
               </a:spcAft>
-              <a:defRPr sz="1100">
+              <a:defRPr sz="1000">
                 <a:solidFill>
                   <a:srgbClr val="F3F4F6"/>
                 </a:solidFill>
               </a:defRPr>
             </a:pPr>
             <a:r>
-              <a:t>• Detection Boundary: H(X) &gt; 3.65 indicates encoded data tunneling or DGA rendezvous.</a:t>
+              <a:t>• Boundary: H(X) &gt; 3.65 indicates encoded data tunneling or DGA rendezvous.</a:t>
             </a:r>
           </a:p>
         </p:txBody>
@@ -5290,8 +5370,112 @@
         </p:nvSpPr>
         <p:spPr>
           <a:xfrm>
-            <a:off x="731520" y="4160520"/>
-            <a:ext cx="5230368" cy="2331720"/>
+            <a:off x="6217920" y="1508760"/>
+            <a:ext cx="5239512" cy="3017520"/>
+          </a:xfrm>
+          <a:prstGeom prst="roundRect">
+            <a:avLst/>
+          </a:prstGeom>
+          <a:solidFill>
+            <a:srgbClr val="111827"/>
+          </a:solidFill>
+          <a:ln w="15240">
+            <a:solidFill>
+              <a:srgbClr val="00E5FF"/>
+            </a:solidFill>
+          </a:ln>
+        </p:spPr>
+        <p:style>
+          <a:lnRef idx="1">
+            <a:schemeClr val="accent1"/>
+          </a:lnRef>
+          <a:fillRef idx="3">
+            <a:schemeClr val="accent1"/>
+          </a:fillRef>
+          <a:effectRef idx="2">
+            <a:schemeClr val="accent1"/>
+          </a:effectRef>
+          <a:fontRef idx="minor">
+            <a:schemeClr val="lt1"/>
+          </a:fontRef>
+        </p:style>
+        <p:txBody>
+          <a:bodyPr rtlCol="0" anchor="ctr"/>
+          <a:lstStyle/>
+          <a:p>
+            <a:pPr algn="ctr"/>
+          </a:p>
+        </p:txBody>
+      </p:sp>
+      <p:pic>
+        <p:nvPicPr>
+          <p:cNvPr id="10" name="Picture 9" descr="packet_dissector.png"/>
+          <p:cNvPicPr>
+            <a:picLocks noChangeAspect="1"/>
+          </p:cNvPicPr>
+          <p:nvPr/>
+        </p:nvPicPr>
+        <p:blipFill>
+          <a:blip r:embed="rId2"/>
+          <a:stretch>
+            <a:fillRect/>
+          </a:stretch>
+        </p:blipFill>
+        <p:spPr>
+          <a:xfrm>
+            <a:off x="6291072" y="1581912"/>
+            <a:ext cx="5093208" cy="2697480"/>
+          </a:xfrm>
+          <a:prstGeom prst="rect">
+            <a:avLst/>
+          </a:prstGeom>
+        </p:spPr>
+      </p:pic>
+      <p:sp>
+        <p:nvSpPr>
+          <p:cNvPr id="11" name="TextBox 10"/>
+          <p:cNvSpPr txBox="1"/>
+          <p:nvPr/>
+        </p:nvSpPr>
+        <p:spPr>
+          <a:xfrm>
+            <a:off x="6217920" y="4233672"/>
+            <a:ext cx="5239512" cy="274320"/>
+          </a:xfrm>
+          <a:prstGeom prst="rect">
+            <a:avLst/>
+          </a:prstGeom>
+          <a:noFill/>
+        </p:spPr>
+        <p:txBody>
+          <a:bodyPr wrap="none">
+            <a:spAutoFit/>
+          </a:bodyPr>
+          <a:lstStyle/>
+          <a:p>
+            <a:pPr algn="ctr">
+              <a:defRPr sz="850" b="1">
+                <a:solidFill>
+                  <a:srgbClr val="00E5FF"/>
+                </a:solidFill>
+              </a:defRPr>
+            </a:pPr>
+            <a:r>
+              <a:t>LIVE DEEP PACKET DISSECTOR (WIRESHARK-STYLE PROTOCOL BREAKDOWN)</a:t>
+            </a:r>
+          </a:p>
+        </p:txBody>
+      </p:sp>
+      <p:sp>
+        <p:nvSpPr>
+          <p:cNvPr id="12" name="Rounded Rectangle 11"/>
+          <p:cNvSpPr/>
+          <p:nvPr/>
+        </p:nvSpPr>
+        <p:spPr>
+          <a:xfrm>
+            <a:off x="6217920" y="4663440"/>
+            <a:ext cx="5239512" cy="1828800"/>
           </a:xfrm>
           <a:prstGeom prst="roundRect">
             <a:avLst/>
@@ -5329,14 +5513,14 @@
       </p:sp>
       <p:sp>
         <p:nvSpPr>
-          <p:cNvPr id="10" name="TextBox 9"/>
+          <p:cNvPr id="13" name="TextBox 12"/>
           <p:cNvSpPr txBox="1"/>
           <p:nvPr/>
         </p:nvSpPr>
         <p:spPr>
           <a:xfrm>
-            <a:off x="868680" y="4270248"/>
-            <a:ext cx="4956048" cy="2112264"/>
+            <a:off x="6345936" y="4754880"/>
+            <a:ext cx="4983480" cy="1645920"/>
           </a:xfrm>
           <a:prstGeom prst="rect">
             <a:avLst/>
@@ -5351,219 +5535,61 @@
           <a:p>
             <a:pPr>
               <a:spcAft>
-                <a:spcPts val="600"/>
-              </a:spcAft>
-              <a:defRPr sz="1400" b="1">
-                <a:solidFill>
-                  <a:srgbClr val="00E5FF"/>
-                </a:solidFill>
-              </a:defRPr>
-            </a:pPr>
-            <a:r>
-              <a:t>3. JA4 TLS CLIENT FINGERPRINTING (RFC 8701)</a:t>
-            </a:r>
-          </a:p>
-          <a:p>
-            <a:pPr>
-              <a:spcAft>
                 <a:spcPts val="400"/>
               </a:spcAft>
-              <a:defRPr sz="1100">
+              <a:defRPr sz="1300" b="1">
+                <a:solidFill>
+                  <a:srgbClr val="00E5FF"/>
+                </a:solidFill>
+              </a:defRPr>
+            </a:pPr>
+            <a:r>
+              <a:t>3. JA4 TLS FINGERPRINTING &amp; VOLUMETRIC SYN FLOOD</a:t>
+            </a:r>
+          </a:p>
+          <a:p>
+            <a:pPr>
+              <a:spcAft>
+                <a:spcPts val="300"/>
+              </a:spcAft>
+              <a:defRPr sz="1000">
                 <a:solidFill>
                   <a:srgbClr val="F3F4F6"/>
                 </a:solidFill>
               </a:defRPr>
             </a:pPr>
             <a:r>
-              <a:t>• Theory: Identifies offensive C2 frameworks (Cobalt Strike, Meterpreter) over HTTPS.</a:t>
+              <a:t>• JA4 RFC 8701: Strips GREASE ciphers; SHA-256 hashes of sorted ciphers and extensions.</a:t>
             </a:r>
           </a:p>
           <a:p>
             <a:pPr>
               <a:spcAft>
-                <a:spcPts val="400"/>
+                <a:spcPts val="300"/>
               </a:spcAft>
-              <a:defRPr sz="1100">
+              <a:defRPr sz="1000">
                 <a:solidFill>
                   <a:srgbClr val="F3F4F6"/>
                 </a:solidFill>
               </a:defRPr>
             </a:pPr>
             <a:r>
-              <a:t>• RFC 8701 GREASE Stripping: Bitmask (val &amp; 0x0F0F) == 0x0A0A eliminates browser noise.</a:t>
+              <a:t>• Signature Match: Identifies Cobalt Strike Malleable C2 profile over encrypted TLS.</a:t>
             </a:r>
           </a:p>
           <a:p>
             <a:pPr>
               <a:spcAft>
-                <a:spcPts val="400"/>
+                <a:spcPts val="300"/>
               </a:spcAft>
-              <a:defRPr sz="1100">
+              <a:defRPr sz="1000">
                 <a:solidFill>
                   <a:srgbClr val="F3F4F6"/>
                 </a:solidFill>
               </a:defRPr>
             </a:pPr>
             <a:r>
-              <a:t>• Canonical String: JA4_A (Proto_Ver_SNI_Ciphers_ALPN) + JA4_B (Cipher SHA-256) + JA4_C (Ext SHA-256).</a:t>
-            </a:r>
-          </a:p>
-          <a:p>
-            <a:pPr>
-              <a:spcAft>
-                <a:spcPts val="400"/>
-              </a:spcAft>
-              <a:defRPr sz="1100">
-                <a:solidFill>
-                  <a:srgbClr val="F3F4F6"/>
-                </a:solidFill>
-              </a:defRPr>
-            </a:pPr>
-            <a:r>
-              <a:t>• Example: t13d1516h2_8daaf6152771_be40b441a884 matches Cobalt Strike Malleable C2 profile.</a:t>
-            </a:r>
-          </a:p>
-        </p:txBody>
-      </p:sp>
-      <p:sp>
-        <p:nvSpPr>
-          <p:cNvPr id="11" name="Rounded Rectangle 10"/>
-          <p:cNvSpPr/>
-          <p:nvPr/>
-        </p:nvSpPr>
-        <p:spPr>
-          <a:xfrm>
-            <a:off x="6217920" y="4160520"/>
-            <a:ext cx="5230368" cy="2331720"/>
-          </a:xfrm>
-          <a:prstGeom prst="roundRect">
-            <a:avLst/>
-          </a:prstGeom>
-          <a:solidFill>
-            <a:srgbClr val="172135"/>
-          </a:solidFill>
-          <a:ln w="15240">
-            <a:solidFill>
-              <a:srgbClr val="25324E"/>
-            </a:solidFill>
-          </a:ln>
-        </p:spPr>
-        <p:style>
-          <a:lnRef idx="1">
-            <a:schemeClr val="accent1"/>
-          </a:lnRef>
-          <a:fillRef idx="3">
-            <a:schemeClr val="accent1"/>
-          </a:fillRef>
-          <a:effectRef idx="2">
-            <a:schemeClr val="accent1"/>
-          </a:effectRef>
-          <a:fontRef idx="minor">
-            <a:schemeClr val="lt1"/>
-          </a:fontRef>
-        </p:style>
-        <p:txBody>
-          <a:bodyPr rtlCol="0" anchor="ctr"/>
-          <a:lstStyle/>
-          <a:p>
-            <a:pPr algn="ctr"/>
-          </a:p>
-        </p:txBody>
-      </p:sp>
-      <p:sp>
-        <p:nvSpPr>
-          <p:cNvPr id="12" name="TextBox 11"/>
-          <p:cNvSpPr txBox="1"/>
-          <p:nvPr/>
-        </p:nvSpPr>
-        <p:spPr>
-          <a:xfrm>
-            <a:off x="6355080" y="4270248"/>
-            <a:ext cx="4956048" cy="2112264"/>
-          </a:xfrm>
-          <a:prstGeom prst="rect">
-            <a:avLst/>
-          </a:prstGeom>
-          <a:noFill/>
-        </p:spPr>
-        <p:txBody>
-          <a:bodyPr wrap="square">
-            <a:spAutoFit/>
-          </a:bodyPr>
-          <a:lstStyle/>
-          <a:p>
-            <a:pPr>
-              <a:spcAft>
-                <a:spcPts val="600"/>
-              </a:spcAft>
-              <a:defRPr sz="1400" b="1">
-                <a:solidFill>
-                  <a:srgbClr val="3B82F6"/>
-                </a:solidFill>
-              </a:defRPr>
-            </a:pPr>
-            <a:r>
-              <a:t>4. VOLUMETRIC SYN FLOOD &amp; PORT RECON SCAN</a:t>
-            </a:r>
-          </a:p>
-          <a:p>
-            <a:pPr>
-              <a:spcAft>
-                <a:spcPts val="400"/>
-              </a:spcAft>
-              <a:defRPr sz="1100">
-                <a:solidFill>
-                  <a:srgbClr val="F3F4F6"/>
-                </a:solidFill>
-              </a:defRPr>
-            </a:pPr>
-            <a:r>
-              <a:t>• Volumetric Inundation: Multi-shard destination aggregation; &gt;75% SYN ratio triggers instant P0 alert.</a:t>
-            </a:r>
-          </a:p>
-          <a:p>
-            <a:pPr>
-              <a:spcAft>
-                <a:spcPts val="400"/>
-              </a:spcAft>
-              <a:defRPr sz="1100">
-                <a:solidFill>
-                  <a:srgbClr val="F3F4F6"/>
-                </a:solidFill>
-              </a:defRPr>
-            </a:pPr>
-            <a:r>
-              <a:t>• Port Reconnaissance Fanout: Cardinality tracking across (src_ip -&gt; {dst_port}) in 3.0s window.</a:t>
-            </a:r>
-          </a:p>
-          <a:p>
-            <a:pPr>
-              <a:spcAft>
-                <a:spcPts val="400"/>
-              </a:spcAft>
-              <a:defRPr sz="1100">
-                <a:solidFill>
-                  <a:srgbClr val="F3F4F6"/>
-                </a:solidFill>
-              </a:defRPr>
-            </a:pPr>
-            <a:r>
-              <a:t>• Dynamic Cardinality: Distinct ports &gt;25 or targets &gt;15 triggers horizontal/vertical scan alert.</a:t>
-            </a:r>
-          </a:p>
-          <a:p>
-            <a:pPr>
-              <a:spcAft>
-                <a:spcPts val="400"/>
-              </a:spcAft>
-              <a:defRPr sz="1100">
-                <a:solidFill>
-                  <a:srgbClr val="F3F4F6"/>
-                </a:solidFill>
-              </a:defRPr>
-            </a:pPr>
-            <a:r>
-              <a:t>• Jitter Engine: Sub-second non-uniform timestamps eliminate artificial, robotic clock patterns.</a:t>
+              <a:t>• Volumetric SYN Flood: &gt;75% SYN ratio in rolling window triggers P0 mitigation.</a:t>
             </a:r>
           </a:p>
         </p:txBody>
@@ -5603,7 +5629,7 @@
         <p:spPr>
           <a:xfrm>
             <a:off x="731520" y="365760"/>
-            <a:ext cx="4114800" cy="320040"/>
+            <a:ext cx="5029200" cy="292608"/>
           </a:xfrm>
           <a:prstGeom prst="rect">
             <a:avLst/>
@@ -5637,8 +5663,8 @@
         </p:nvSpPr>
         <p:spPr>
           <a:xfrm>
-            <a:off x="731520" y="640080"/>
-            <a:ext cx="10698480" cy="548640"/>
+            <a:off x="731520" y="621792"/>
+            <a:ext cx="10698480" cy="502920"/>
           </a:xfrm>
           <a:prstGeom prst="rect">
             <a:avLst/>
@@ -5652,7 +5678,7 @@
           <a:lstStyle/>
           <a:p>
             <a:pPr>
-              <a:defRPr sz="2200" b="1">
+              <a:defRPr sz="2100" b="1">
                 <a:solidFill>
                   <a:srgbClr val="F3F4F6"/>
                 </a:solidFill>
@@ -5672,8 +5698,8 @@
         </p:nvSpPr>
         <p:spPr>
           <a:xfrm>
-            <a:off x="731520" y="1143000"/>
-            <a:ext cx="10698480" cy="365760"/>
+            <a:off x="731520" y="1097280"/>
+            <a:ext cx="10698480" cy="320040"/>
           </a:xfrm>
           <a:prstGeom prst="rect">
             <a:avLst/>
@@ -5687,7 +5713,7 @@
           <a:lstStyle/>
           <a:p>
             <a:pPr>
-              <a:defRPr sz="1200">
+              <a:defRPr sz="1150">
                 <a:solidFill>
                   <a:srgbClr val="9CA3AF"/>
                 </a:solidFill>
@@ -5707,8 +5733,112 @@
         </p:nvSpPr>
         <p:spPr>
           <a:xfrm>
-            <a:off x="731520" y="1645920"/>
-            <a:ext cx="3429000" cy="4709160"/>
+            <a:off x="731520" y="1508760"/>
+            <a:ext cx="5230368" cy="3154680"/>
+          </a:xfrm>
+          <a:prstGeom prst="roundRect">
+            <a:avLst/>
+          </a:prstGeom>
+          <a:solidFill>
+            <a:srgbClr val="111827"/>
+          </a:solidFill>
+          <a:ln w="15240">
+            <a:solidFill>
+              <a:srgbClr val="00E5FF"/>
+            </a:solidFill>
+          </a:ln>
+        </p:spPr>
+        <p:style>
+          <a:lnRef idx="1">
+            <a:schemeClr val="accent1"/>
+          </a:lnRef>
+          <a:fillRef idx="3">
+            <a:schemeClr val="accent1"/>
+          </a:fillRef>
+          <a:effectRef idx="2">
+            <a:schemeClr val="accent1"/>
+          </a:effectRef>
+          <a:fontRef idx="minor">
+            <a:schemeClr val="lt1"/>
+          </a:fontRef>
+        </p:style>
+        <p:txBody>
+          <a:bodyPr rtlCol="0" anchor="ctr"/>
+          <a:lstStyle/>
+          <a:p>
+            <a:pPr algn="ctr"/>
+          </a:p>
+        </p:txBody>
+      </p:sp>
+      <p:pic>
+        <p:nvPicPr>
+          <p:cNvPr id="6" name="Picture 5" descr="mitre_matrix.png"/>
+          <p:cNvPicPr>
+            <a:picLocks noChangeAspect="1"/>
+          </p:cNvPicPr>
+          <p:nvPr/>
+        </p:nvPicPr>
+        <p:blipFill>
+          <a:blip r:embed="rId2"/>
+          <a:stretch>
+            <a:fillRect/>
+          </a:stretch>
+        </p:blipFill>
+        <p:spPr>
+          <a:xfrm>
+            <a:off x="804672" y="1581912"/>
+            <a:ext cx="5084064" cy="2834640"/>
+          </a:xfrm>
+          <a:prstGeom prst="rect">
+            <a:avLst/>
+          </a:prstGeom>
+        </p:spPr>
+      </p:pic>
+      <p:sp>
+        <p:nvSpPr>
+          <p:cNvPr id="7" name="TextBox 6"/>
+          <p:cNvSpPr txBox="1"/>
+          <p:nvPr/>
+        </p:nvSpPr>
+        <p:spPr>
+          <a:xfrm>
+            <a:off x="731520" y="4370832"/>
+            <a:ext cx="5230368" cy="274320"/>
+          </a:xfrm>
+          <a:prstGeom prst="rect">
+            <a:avLst/>
+          </a:prstGeom>
+          <a:noFill/>
+        </p:spPr>
+        <p:txBody>
+          <a:bodyPr wrap="none">
+            <a:spAutoFit/>
+          </a:bodyPr>
+          <a:lstStyle/>
+          <a:p>
+            <a:pPr algn="ctr">
+              <a:defRPr sz="850" b="1">
+                <a:solidFill>
+                  <a:srgbClr val="00E5FF"/>
+                </a:solidFill>
+              </a:defRPr>
+            </a:pPr>
+            <a:r>
+              <a:t>VERIFIED MITRE ATT&amp;CK ENTERPRISE MATRIX (14 ACTIVE TACTICS)</a:t>
+            </a:r>
+          </a:p>
+        </p:txBody>
+      </p:sp>
+      <p:sp>
+        <p:nvSpPr>
+          <p:cNvPr id="8" name="Rounded Rectangle 7"/>
+          <p:cNvSpPr/>
+          <p:nvPr/>
+        </p:nvSpPr>
+        <p:spPr>
+          <a:xfrm>
+            <a:off x="731520" y="4800600"/>
+            <a:ext cx="5230368" cy="1691640"/>
           </a:xfrm>
           <a:prstGeom prst="roundRect">
             <a:avLst/>
@@ -5746,14 +5876,14 @@
       </p:sp>
       <p:sp>
         <p:nvSpPr>
-          <p:cNvPr id="6" name="TextBox 5"/>
+          <p:cNvPr id="9" name="TextBox 8"/>
           <p:cNvSpPr txBox="1"/>
           <p:nvPr/>
         </p:nvSpPr>
         <p:spPr>
           <a:xfrm>
-            <a:off x="868680" y="1755648"/>
-            <a:ext cx="3154680" cy="4489704"/>
+            <a:off x="859536" y="4892040"/>
+            <a:ext cx="4974336" cy="1508760"/>
           </a:xfrm>
           <a:prstGeom prst="rect">
             <a:avLst/>
@@ -5768,324 +5898,179 @@
           <a:p>
             <a:pPr>
               <a:spcAft>
-                <a:spcPts val="600"/>
-              </a:spcAft>
-              <a:defRPr sz="1400" b="1">
-                <a:solidFill>
-                  <a:srgbClr val="00E5FF"/>
-                </a:solidFill>
-              </a:defRPr>
-            </a:pPr>
-            <a:r>
-              <a:t>MITRE ATT&amp;CK ENCLAVE</a:t>
-            </a:r>
-          </a:p>
-          <a:p>
-            <a:pPr>
-              <a:spcAft>
                 <a:spcPts val="400"/>
               </a:spcAft>
-              <a:defRPr sz="1100">
+              <a:defRPr sz="1300" b="1">
+                <a:solidFill>
+                  <a:srgbClr val="F59E0B"/>
+                </a:solidFill>
+              </a:defRPr>
+            </a:pPr>
+            <a:r>
+              <a:t>BLAST RADIUS &amp; MERKLE AUDIT LEDGER</a:t>
+            </a:r>
+          </a:p>
+          <a:p>
+            <a:pPr>
+              <a:spcAft>
+                <a:spcPts val="300"/>
+              </a:spcAft>
+              <a:defRPr sz="1000">
                 <a:solidFill>
                   <a:srgbClr val="F3F4F6"/>
                 </a:solidFill>
               </a:defRPr>
             </a:pPr>
             <a:r>
-              <a:t>• 14 Enterprise Tactics Mapped:</a:t>
+              <a:t>• Topology-Aware Risk: Evaluates exposure across Domain Controllers and DBs.</a:t>
             </a:r>
           </a:p>
           <a:p>
             <a:pPr>
               <a:spcAft>
-                <a:spcPts val="400"/>
+                <a:spcPts val="300"/>
               </a:spcAft>
-              <a:defRPr sz="1100">
+              <a:defRPr sz="1000">
                 <a:solidFill>
                   <a:srgbClr val="F3F4F6"/>
                 </a:solidFill>
               </a:defRPr>
             </a:pPr>
             <a:r>
-              <a:t>  - Reconnaissance (TA0043)</a:t>
+              <a:t>• Merkle Hash-Chaining: Sequential SHA-256 ledger guarantees immutable audit trail.</a:t>
             </a:r>
           </a:p>
           <a:p>
             <a:pPr>
               <a:spcAft>
-                <a:spcPts val="400"/>
+                <a:spcPts val="300"/>
               </a:spcAft>
-              <a:defRPr sz="1100">
+              <a:defRPr sz="1000">
                 <a:solidFill>
                   <a:srgbClr val="F3F4F6"/>
                 </a:solidFill>
               </a:defRPr>
             </a:pPr>
             <a:r>
-              <a:t>  - Initial Access (TA0001)</a:t>
-            </a:r>
-          </a:p>
-          <a:p>
-            <a:pPr>
-              <a:spcAft>
-                <a:spcPts val="400"/>
-              </a:spcAft>
-              <a:defRPr sz="1100">
-                <a:solidFill>
-                  <a:srgbClr val="F3F4F6"/>
-                </a:solidFill>
-              </a:defRPr>
-            </a:pPr>
-            <a:r>
-              <a:t>  - Execution (TA0002)</a:t>
-            </a:r>
-          </a:p>
-          <a:p>
-            <a:pPr>
-              <a:spcAft>
-                <a:spcPts val="400"/>
-              </a:spcAft>
-              <a:defRPr sz="1100">
-                <a:solidFill>
-                  <a:srgbClr val="F3F4F6"/>
-                </a:solidFill>
-              </a:defRPr>
-            </a:pPr>
-            <a:r>
-              <a:t>  - Defense Evasion (TA0005)</a:t>
-            </a:r>
-          </a:p>
-          <a:p>
-            <a:pPr>
-              <a:spcAft>
-                <a:spcPts val="400"/>
-              </a:spcAft>
-              <a:defRPr sz="1100">
-                <a:solidFill>
-                  <a:srgbClr val="F3F4F6"/>
-                </a:solidFill>
-              </a:defRPr>
-            </a:pPr>
-            <a:r>
-              <a:t>  - Credential Access (TA0006)</a:t>
-            </a:r>
-          </a:p>
-          <a:p>
-            <a:pPr>
-              <a:spcAft>
-                <a:spcPts val="400"/>
-              </a:spcAft>
-              <a:defRPr sz="1100">
-                <a:solidFill>
-                  <a:srgbClr val="F3F4F6"/>
-                </a:solidFill>
-              </a:defRPr>
-            </a:pPr>
-            <a:r>
-              <a:t>  - Discovery (TA0007)</a:t>
-            </a:r>
-          </a:p>
-          <a:p>
-            <a:pPr>
-              <a:spcAft>
-                <a:spcPts val="400"/>
-              </a:spcAft>
-              <a:defRPr sz="1100">
-                <a:solidFill>
-                  <a:srgbClr val="F3F4F6"/>
-                </a:solidFill>
-              </a:defRPr>
-            </a:pPr>
-            <a:r>
-              <a:t>  - Command &amp; Control (TA0011)</a:t>
-            </a:r>
-          </a:p>
-          <a:p>
-            <a:pPr>
-              <a:spcAft>
-                <a:spcPts val="400"/>
-              </a:spcAft>
-              <a:defRPr sz="1100">
-                <a:solidFill>
-                  <a:srgbClr val="F3F4F6"/>
-                </a:solidFill>
-              </a:defRPr>
-            </a:pPr>
-            <a:r>
-              <a:t>  - Exfiltration (TA0010)</a:t>
-            </a:r>
-          </a:p>
-          <a:p>
-            <a:pPr>
-              <a:spcAft>
-                <a:spcPts val="400"/>
-              </a:spcAft>
-              <a:defRPr sz="1100">
-                <a:solidFill>
-                  <a:srgbClr val="F3F4F6"/>
-                </a:solidFill>
-              </a:defRPr>
-            </a:pPr>
-            <a:r>
-              <a:t>  - Impact (TA0040)</a:t>
-            </a:r>
-          </a:p>
-          <a:p>
-            <a:pPr>
-              <a:spcAft>
-                <a:spcPts val="400"/>
-              </a:spcAft>
-              <a:defRPr sz="1100">
-                <a:solidFill>
-                  <a:srgbClr val="F3F4F6"/>
-                </a:solidFill>
-              </a:defRPr>
-            </a:pPr>
-          </a:p>
-          <a:p>
-            <a:pPr>
-              <a:spcAft>
-                <a:spcPts val="400"/>
-              </a:spcAft>
-              <a:defRPr sz="1100">
-                <a:solidFill>
-                  <a:srgbClr val="F3F4F6"/>
-                </a:solidFill>
-              </a:defRPr>
-            </a:pPr>
-            <a:r>
-              <a:t>• Automated Technique Binding:</a:t>
-            </a:r>
-          </a:p>
-          <a:p>
-            <a:pPr>
-              <a:spcAft>
-                <a:spcPts val="400"/>
-              </a:spcAft>
-              <a:defRPr sz="1100">
-                <a:solidFill>
-                  <a:srgbClr val="F3F4F6"/>
-                </a:solidFill>
-              </a:defRPr>
-            </a:pPr>
-            <a:r>
-              <a:t>  - T1498.001 (SYN Flood Exhaustion)</a:t>
-            </a:r>
-          </a:p>
-          <a:p>
-            <a:pPr>
-              <a:spcAft>
-                <a:spcPts val="400"/>
-              </a:spcAft>
-              <a:defRPr sz="1100">
-                <a:solidFill>
-                  <a:srgbClr val="F3F4F6"/>
-                </a:solidFill>
-              </a:defRPr>
-            </a:pPr>
-            <a:r>
-              <a:t>  - T1071.001 (Web C2 Beaconing)</a:t>
-            </a:r>
-          </a:p>
-          <a:p>
-            <a:pPr>
-              <a:spcAft>
-                <a:spcPts val="400"/>
-              </a:spcAft>
-              <a:defRPr sz="1100">
-                <a:solidFill>
-                  <a:srgbClr val="F3F4F6"/>
-                </a:solidFill>
-              </a:defRPr>
-            </a:pPr>
-            <a:r>
-              <a:t>  - T1046 (Port Recon Discovery)</a:t>
-            </a:r>
-          </a:p>
-          <a:p>
-            <a:pPr>
-              <a:spcAft>
-                <a:spcPts val="400"/>
-              </a:spcAft>
-              <a:defRPr sz="1100">
-                <a:solidFill>
-                  <a:srgbClr val="F3F4F6"/>
-                </a:solidFill>
-              </a:defRPr>
-            </a:pPr>
-            <a:r>
-              <a:t>  - T1568.002 (Domain Generation DGA)</a:t>
-            </a:r>
-          </a:p>
-          <a:p>
-            <a:pPr>
-              <a:spcAft>
-                <a:spcPts val="400"/>
-              </a:spcAft>
-              <a:defRPr sz="1100">
-                <a:solidFill>
-                  <a:srgbClr val="F3F4F6"/>
-                </a:solidFill>
-              </a:defRPr>
-            </a:pPr>
-            <a:r>
-              <a:t>  - T1573.002 (Asymmetric TLS C2)</a:t>
-            </a:r>
-          </a:p>
-          <a:p>
-            <a:pPr>
-              <a:spcAft>
-                <a:spcPts val="400"/>
-              </a:spcAft>
-              <a:defRPr sz="1100">
-                <a:solidFill>
-                  <a:srgbClr val="F3F4F6"/>
-                </a:solidFill>
-              </a:defRPr>
-            </a:pPr>
-          </a:p>
-          <a:p>
-            <a:pPr>
-              <a:spcAft>
-                <a:spcPts val="400"/>
-              </a:spcAft>
-              <a:defRPr sz="1100">
-                <a:solidFill>
-                  <a:srgbClr val="F3F4F6"/>
-                </a:solidFill>
-              </a:defRPr>
-            </a:pPr>
-            <a:r>
-              <a:t>• Threat Actor Attribution:</a:t>
-            </a:r>
-          </a:p>
-          <a:p>
-            <a:pPr>
-              <a:spcAft>
-                <a:spcPts val="400"/>
-              </a:spcAft>
-              <a:defRPr sz="1100">
-                <a:solidFill>
-                  <a:srgbClr val="F3F4F6"/>
-                </a:solidFill>
-              </a:defRPr>
-            </a:pPr>
-            <a:r>
-              <a:t>  Direct mapping to APT28, Mirai, Cobalt Strike, and LockBit affiliates.</a:t>
-            </a:r>
-          </a:p>
-        </p:txBody>
-      </p:sp>
-      <p:sp>
-        <p:nvSpPr>
-          <p:cNvPr id="7" name="Rounded Rectangle 6"/>
+              <a:t>• LLM Triage Hook: Optional Gemini API integration for semantic incident reporting.</a:t>
+            </a:r>
+          </a:p>
+        </p:txBody>
+      </p:sp>
+      <p:sp>
+        <p:nvSpPr>
+          <p:cNvPr id="10" name="Rounded Rectangle 9"/>
           <p:cNvSpPr/>
           <p:nvPr/>
         </p:nvSpPr>
         <p:spPr>
           <a:xfrm>
-            <a:off x="4370832" y="1645920"/>
-            <a:ext cx="3429000" cy="4709160"/>
+            <a:off x="6217920" y="1508760"/>
+            <a:ext cx="5239512" cy="3154680"/>
+          </a:xfrm>
+          <a:prstGeom prst="roundRect">
+            <a:avLst/>
+          </a:prstGeom>
+          <a:solidFill>
+            <a:srgbClr val="111827"/>
+          </a:solidFill>
+          <a:ln w="15240">
+            <a:solidFill>
+              <a:srgbClr val="00E5FF"/>
+            </a:solidFill>
+          </a:ln>
+        </p:spPr>
+        <p:style>
+          <a:lnRef idx="1">
+            <a:schemeClr val="accent1"/>
+          </a:lnRef>
+          <a:fillRef idx="3">
+            <a:schemeClr val="accent1"/>
+          </a:fillRef>
+          <a:effectRef idx="2">
+            <a:schemeClr val="accent1"/>
+          </a:effectRef>
+          <a:fontRef idx="minor">
+            <a:schemeClr val="lt1"/>
+          </a:fontRef>
+        </p:style>
+        <p:txBody>
+          <a:bodyPr rtlCol="0" anchor="ctr"/>
+          <a:lstStyle/>
+          <a:p>
+            <a:pPr algn="ctr"/>
+          </a:p>
+        </p:txBody>
+      </p:sp>
+      <p:pic>
+        <p:nvPicPr>
+          <p:cNvPr id="11" name="Picture 10" descr="mitigation_rules.png"/>
+          <p:cNvPicPr>
+            <a:picLocks noChangeAspect="1"/>
+          </p:cNvPicPr>
+          <p:nvPr/>
+        </p:nvPicPr>
+        <p:blipFill>
+          <a:blip r:embed="rId3"/>
+          <a:stretch>
+            <a:fillRect/>
+          </a:stretch>
+        </p:blipFill>
+        <p:spPr>
+          <a:xfrm>
+            <a:off x="6291072" y="1581912"/>
+            <a:ext cx="5093208" cy="2834640"/>
+          </a:xfrm>
+          <a:prstGeom prst="rect">
+            <a:avLst/>
+          </a:prstGeom>
+        </p:spPr>
+      </p:pic>
+      <p:sp>
+        <p:nvSpPr>
+          <p:cNvPr id="12" name="TextBox 11"/>
+          <p:cNvSpPr txBox="1"/>
+          <p:nvPr/>
+        </p:nvSpPr>
+        <p:spPr>
+          <a:xfrm>
+            <a:off x="6217920" y="4370832"/>
+            <a:ext cx="5239512" cy="274320"/>
+          </a:xfrm>
+          <a:prstGeom prst="rect">
+            <a:avLst/>
+          </a:prstGeom>
+          <a:noFill/>
+        </p:spPr>
+        <p:txBody>
+          <a:bodyPr wrap="none">
+            <a:spAutoFit/>
+          </a:bodyPr>
+          <a:lstStyle/>
+          <a:p>
+            <a:pPr algn="ctr">
+              <a:defRPr sz="850" b="1">
+                <a:solidFill>
+                  <a:srgbClr val="00E5FF"/>
+                </a:solidFill>
+              </a:defRPr>
+            </a:pPr>
+            <a:r>
+              <a:t>LIVE DYNAMIC FIREWALL &amp; IDS RULE SYNTHESIZER (5 FORMATS)</a:t>
+            </a:r>
+          </a:p>
+        </p:txBody>
+      </p:sp>
+      <p:sp>
+        <p:nvSpPr>
+          <p:cNvPr id="13" name="Rounded Rectangle 12"/>
+          <p:cNvSpPr/>
+          <p:nvPr/>
+        </p:nvSpPr>
+        <p:spPr>
+          <a:xfrm>
+            <a:off x="6217920" y="4800600"/>
+            <a:ext cx="5239512" cy="1691640"/>
           </a:xfrm>
           <a:prstGeom prst="roundRect">
             <a:avLst/>
@@ -6123,14 +6108,14 @@
       </p:sp>
       <p:sp>
         <p:nvSpPr>
-          <p:cNvPr id="8" name="TextBox 7"/>
+          <p:cNvPr id="14" name="TextBox 13"/>
           <p:cNvSpPr txBox="1"/>
           <p:nvPr/>
         </p:nvSpPr>
         <p:spPr>
           <a:xfrm>
-            <a:off x="4507992" y="1755648"/>
-            <a:ext cx="3154680" cy="4489704"/>
+            <a:off x="6345936" y="4892040"/>
+            <a:ext cx="4983480" cy="1508760"/>
           </a:xfrm>
           <a:prstGeom prst="rect">
             <a:avLst/>
@@ -6145,552 +6130,61 @@
           <a:p>
             <a:pPr>
               <a:spcAft>
-                <a:spcPts val="600"/>
-              </a:spcAft>
-              <a:defRPr sz="1400" b="1">
-                <a:solidFill>
-                  <a:srgbClr val="F59E0B"/>
-                </a:solidFill>
-              </a:defRPr>
-            </a:pPr>
-            <a:r>
-              <a:t>BLAST RADIUS &amp; PLAYBOOKS</a:t>
-            </a:r>
-          </a:p>
-          <a:p>
-            <a:pPr>
-              <a:spcAft>
                 <a:spcPts val="400"/>
               </a:spcAft>
-              <a:defRPr sz="1100">
+              <a:defRPr sz="1300" b="1">
+                <a:solidFill>
+                  <a:srgbClr val="10B981"/>
+                </a:solidFill>
+              </a:defRPr>
+            </a:pPr>
+            <a:r>
+              <a:t>AUTOMATED RULE SYNTHESIS EXPORTS</a:t>
+            </a:r>
+          </a:p>
+          <a:p>
+            <a:pPr>
+              <a:spcAft>
+                <a:spcPts val="300"/>
+              </a:spcAft>
+              <a:defRPr sz="1000">
                 <a:solidFill>
                   <a:srgbClr val="F3F4F6"/>
                 </a:solidFill>
               </a:defRPr>
             </a:pPr>
             <a:r>
-              <a:t>• Topology-Aware Risk Scoring:</a:t>
+              <a:t>• Linux IPTables: iptables -A INPUT -p tcp --dport 443 -m hashlimit --hashlimit-above 50/sec -j DROP</a:t>
             </a:r>
           </a:p>
           <a:p>
             <a:pPr>
               <a:spcAft>
-                <a:spcPts val="400"/>
+                <a:spcPts val="300"/>
               </a:spcAft>
-              <a:defRPr sz="1100">
+              <a:defRPr sz="1000">
                 <a:solidFill>
                   <a:srgbClr val="F3F4F6"/>
                 </a:solidFill>
               </a:defRPr>
             </a:pPr>
             <a:r>
-              <a:t>  Evaluates target host sensitivity (Domain Controller, Database, Workstation).</a:t>
+              <a:t>• Linux NFTables: table inet filter { chain input { tcp flags syn meter ... drop } }</a:t>
             </a:r>
           </a:p>
           <a:p>
             <a:pPr>
               <a:spcAft>
-                <a:spcPts val="400"/>
+                <a:spcPts val="300"/>
               </a:spcAft>
-              <a:defRPr sz="1100">
+              <a:defRPr sz="1000">
                 <a:solidFill>
                   <a:srgbClr val="F3F4F6"/>
                 </a:solidFill>
               </a:defRPr>
             </a:pPr>
-          </a:p>
-          <a:p>
-            <a:pPr>
-              <a:spcAft>
-                <a:spcPts val="400"/>
-              </a:spcAft>
-              <a:defRPr sz="1100">
-                <a:solidFill>
-                  <a:srgbClr val="F3F4F6"/>
-                </a:solidFill>
-              </a:defRPr>
-            </a:pPr>
-            <a:r>
-              <a:t>• Lateral Movement Modeling:</a:t>
-            </a:r>
-          </a:p>
-          <a:p>
-            <a:pPr>
-              <a:spcAft>
-                <a:spcPts val="400"/>
-              </a:spcAft>
-              <a:defRPr sz="1100">
-                <a:solidFill>
-                  <a:srgbClr val="F3F4F6"/>
-                </a:solidFill>
-              </a:defRPr>
-            </a:pPr>
-            <a:r>
-              <a:t>  Calculates probability of attacker pivot across subnet boundaries.</a:t>
-            </a:r>
-          </a:p>
-          <a:p>
-            <a:pPr>
-              <a:spcAft>
-                <a:spcPts val="400"/>
-              </a:spcAft>
-              <a:defRPr sz="1100">
-                <a:solidFill>
-                  <a:srgbClr val="F3F4F6"/>
-                </a:solidFill>
-              </a:defRPr>
-            </a:pPr>
-          </a:p>
-          <a:p>
-            <a:pPr>
-              <a:spcAft>
-                <a:spcPts val="400"/>
-              </a:spcAft>
-              <a:defRPr sz="1100">
-                <a:solidFill>
-                  <a:srgbClr val="F3F4F6"/>
-                </a:solidFill>
-              </a:defRPr>
-            </a:pPr>
-            <a:r>
-              <a:t>• Step-by-Step Playbook Generation:</a:t>
-            </a:r>
-          </a:p>
-          <a:p>
-            <a:pPr>
-              <a:spcAft>
-                <a:spcPts val="400"/>
-              </a:spcAft>
-              <a:defRPr sz="1100">
-                <a:solidFill>
-                  <a:srgbClr val="F3F4F6"/>
-                </a:solidFill>
-              </a:defRPr>
-            </a:pPr>
-            <a:r>
-              <a:t>  - Step 1 (P0): Kernel SYN cookies / Host Isolation</a:t>
-            </a:r>
-          </a:p>
-          <a:p>
-            <a:pPr>
-              <a:spcAft>
-                <a:spcPts val="400"/>
-              </a:spcAft>
-              <a:defRPr sz="1100">
-                <a:solidFill>
-                  <a:srgbClr val="F3F4F6"/>
-                </a:solidFill>
-              </a:defRPr>
-            </a:pPr>
-            <a:r>
-              <a:t>  - Step 2 (P1): Perimeter IP Drop / Route Blackhole</a:t>
-            </a:r>
-          </a:p>
-          <a:p>
-            <a:pPr>
-              <a:spcAft>
-                <a:spcPts val="400"/>
-              </a:spcAft>
-              <a:defRPr sz="1100">
-                <a:solidFill>
-                  <a:srgbClr val="F3F4F6"/>
-                </a:solidFill>
-              </a:defRPr>
-            </a:pPr>
-            <a:r>
-              <a:t>  - Step 3 (P2): EDR memory dump &amp; Kerberos token revocation</a:t>
-            </a:r>
-          </a:p>
-          <a:p>
-            <a:pPr>
-              <a:spcAft>
-                <a:spcPts val="400"/>
-              </a:spcAft>
-              <a:defRPr sz="1100">
-                <a:solidFill>
-                  <a:srgbClr val="F3F4F6"/>
-                </a:solidFill>
-              </a:defRPr>
-            </a:pPr>
-          </a:p>
-          <a:p>
-            <a:pPr>
-              <a:spcAft>
-                <a:spcPts val="400"/>
-              </a:spcAft>
-              <a:defRPr sz="1100">
-                <a:solidFill>
-                  <a:srgbClr val="F3F4F6"/>
-                </a:solidFill>
-              </a:defRPr>
-            </a:pPr>
-            <a:r>
-              <a:t>• Cryptographic Merkle Audit Log:</a:t>
-            </a:r>
-          </a:p>
-          <a:p>
-            <a:pPr>
-              <a:spcAft>
-                <a:spcPts val="400"/>
-              </a:spcAft>
-              <a:defRPr sz="1100">
-                <a:solidFill>
-                  <a:srgbClr val="F3F4F6"/>
-                </a:solidFill>
-              </a:defRPr>
-            </a:pPr>
-            <a:r>
-              <a:t>  Sequential SHA-256 hash-chaining prevents retroactive tampering of forensic logs.</a:t>
-            </a:r>
-          </a:p>
-          <a:p>
-            <a:pPr>
-              <a:spcAft>
-                <a:spcPts val="400"/>
-              </a:spcAft>
-              <a:defRPr sz="1100">
-                <a:solidFill>
-                  <a:srgbClr val="F3F4F6"/>
-                </a:solidFill>
-              </a:defRPr>
-            </a:pPr>
-          </a:p>
-          <a:p>
-            <a:pPr>
-              <a:spcAft>
-                <a:spcPts val="400"/>
-              </a:spcAft>
-              <a:defRPr sz="1100">
-                <a:solidFill>
-                  <a:srgbClr val="F3F4F6"/>
-                </a:solidFill>
-              </a:defRPr>
-            </a:pPr>
-            <a:r>
-              <a:t>• Optional LLM Reasoning Hook:</a:t>
-            </a:r>
-          </a:p>
-          <a:p>
-            <a:pPr>
-              <a:spcAft>
-                <a:spcPts val="400"/>
-              </a:spcAft>
-              <a:defRPr sz="1100">
-                <a:solidFill>
-                  <a:srgbClr val="F3F4F6"/>
-                </a:solidFill>
-              </a:defRPr>
-            </a:pPr>
-            <a:r>
-              <a:t>  Native support for Google Gemini API for natural language threat explanation.</a:t>
-            </a:r>
-          </a:p>
-        </p:txBody>
-      </p:sp>
-      <p:sp>
-        <p:nvSpPr>
-          <p:cNvPr id="9" name="Rounded Rectangle 8"/>
-          <p:cNvSpPr/>
-          <p:nvPr/>
-        </p:nvSpPr>
-        <p:spPr>
-          <a:xfrm>
-            <a:off x="8010144" y="1645920"/>
-            <a:ext cx="3429000" cy="4709160"/>
-          </a:xfrm>
-          <a:prstGeom prst="roundRect">
-            <a:avLst/>
-          </a:prstGeom>
-          <a:solidFill>
-            <a:srgbClr val="172135"/>
-          </a:solidFill>
-          <a:ln w="15240">
-            <a:solidFill>
-              <a:srgbClr val="25324E"/>
-            </a:solidFill>
-          </a:ln>
-        </p:spPr>
-        <p:style>
-          <a:lnRef idx="1">
-            <a:schemeClr val="accent1"/>
-          </a:lnRef>
-          <a:fillRef idx="3">
-            <a:schemeClr val="accent1"/>
-          </a:fillRef>
-          <a:effectRef idx="2">
-            <a:schemeClr val="accent1"/>
-          </a:effectRef>
-          <a:fontRef idx="minor">
-            <a:schemeClr val="lt1"/>
-          </a:fontRef>
-        </p:style>
-        <p:txBody>
-          <a:bodyPr rtlCol="0" anchor="ctr"/>
-          <a:lstStyle/>
-          <a:p>
-            <a:pPr algn="ctr"/>
-          </a:p>
-        </p:txBody>
-      </p:sp>
-      <p:sp>
-        <p:nvSpPr>
-          <p:cNvPr id="10" name="TextBox 9"/>
-          <p:cNvSpPr txBox="1"/>
-          <p:nvPr/>
-        </p:nvSpPr>
-        <p:spPr>
-          <a:xfrm>
-            <a:off x="8147304" y="1755648"/>
-            <a:ext cx="3154680" cy="4489704"/>
-          </a:xfrm>
-          <a:prstGeom prst="rect">
-            <a:avLst/>
-          </a:prstGeom>
-          <a:noFill/>
-        </p:spPr>
-        <p:txBody>
-          <a:bodyPr wrap="square">
-            <a:spAutoFit/>
-          </a:bodyPr>
-          <a:lstStyle/>
-          <a:p>
-            <a:pPr>
-              <a:spcAft>
-                <a:spcPts val="600"/>
-              </a:spcAft>
-              <a:defRPr sz="1400" b="1">
-                <a:solidFill>
-                  <a:srgbClr val="10B981"/>
-                </a:solidFill>
-              </a:defRPr>
-            </a:pPr>
-            <a:r>
-              <a:t>DYNAMIC RULE SYNTHESIS</a:t>
-            </a:r>
-          </a:p>
-          <a:p>
-            <a:pPr>
-              <a:spcAft>
-                <a:spcPts val="400"/>
-              </a:spcAft>
-              <a:defRPr sz="1100">
-                <a:solidFill>
-                  <a:srgbClr val="F3F4F6"/>
-                </a:solidFill>
-              </a:defRPr>
-            </a:pPr>
-            <a:r>
-              <a:t>Instant translation of alerts into 5 production-grade defense formats:</a:t>
-            </a:r>
-          </a:p>
-          <a:p>
-            <a:pPr>
-              <a:spcAft>
-                <a:spcPts val="400"/>
-              </a:spcAft>
-              <a:defRPr sz="1100">
-                <a:solidFill>
-                  <a:srgbClr val="F3F4F6"/>
-                </a:solidFill>
-              </a:defRPr>
-            </a:pPr>
-          </a:p>
-          <a:p>
-            <a:pPr>
-              <a:spcAft>
-                <a:spcPts val="400"/>
-              </a:spcAft>
-              <a:defRPr sz="1100">
-                <a:solidFill>
-                  <a:srgbClr val="F3F4F6"/>
-                </a:solidFill>
-              </a:defRPr>
-            </a:pPr>
-            <a:r>
-              <a:t>1. Linux IPTables:</a:t>
-            </a:r>
-          </a:p>
-          <a:p>
-            <a:pPr>
-              <a:spcAft>
-                <a:spcPts val="400"/>
-              </a:spcAft>
-              <a:defRPr sz="1100">
-                <a:solidFill>
-                  <a:srgbClr val="F3F4F6"/>
-                </a:solidFill>
-              </a:defRPr>
-            </a:pPr>
-            <a:r>
-              <a:t>   iptables -A INPUT -p tcp --dport 443 -m hashlimit --hashlimit-above 50/sec -j DROP</a:t>
-            </a:r>
-          </a:p>
-          <a:p>
-            <a:pPr>
-              <a:spcAft>
-                <a:spcPts val="400"/>
-              </a:spcAft>
-              <a:defRPr sz="1100">
-                <a:solidFill>
-                  <a:srgbClr val="F3F4F6"/>
-                </a:solidFill>
-              </a:defRPr>
-            </a:pPr>
-          </a:p>
-          <a:p>
-            <a:pPr>
-              <a:spcAft>
-                <a:spcPts val="400"/>
-              </a:spcAft>
-              <a:defRPr sz="1100">
-                <a:solidFill>
-                  <a:srgbClr val="F3F4F6"/>
-                </a:solidFill>
-              </a:defRPr>
-            </a:pPr>
-            <a:r>
-              <a:t>2. Linux NFTables:</a:t>
-            </a:r>
-          </a:p>
-          <a:p>
-            <a:pPr>
-              <a:spcAft>
-                <a:spcPts val="400"/>
-              </a:spcAft>
-              <a:defRPr sz="1100">
-                <a:solidFill>
-                  <a:srgbClr val="F3F4F6"/>
-                </a:solidFill>
-              </a:defRPr>
-            </a:pPr>
-            <a:r>
-              <a:t>   table inet filter { chain input { tcp flags syn meter syn-meter { ip saddr limit rate over 50/sec } drop } }</a:t>
-            </a:r>
-          </a:p>
-          <a:p>
-            <a:pPr>
-              <a:spcAft>
-                <a:spcPts val="400"/>
-              </a:spcAft>
-              <a:defRPr sz="1100">
-                <a:solidFill>
-                  <a:srgbClr val="F3F4F6"/>
-                </a:solidFill>
-              </a:defRPr>
-            </a:pPr>
-          </a:p>
-          <a:p>
-            <a:pPr>
-              <a:spcAft>
-                <a:spcPts val="400"/>
-              </a:spcAft>
-              <a:defRPr sz="1100">
-                <a:solidFill>
-                  <a:srgbClr val="F3F4F6"/>
-                </a:solidFill>
-              </a:defRPr>
-            </a:pPr>
-            <a:r>
-              <a:t>3. Suricata IDS Rule:</a:t>
-            </a:r>
-          </a:p>
-          <a:p>
-            <a:pPr>
-              <a:spcAft>
-                <a:spcPts val="400"/>
-              </a:spcAft>
-              <a:defRPr sz="1100">
-                <a:solidFill>
-                  <a:srgbClr val="F3F4F6"/>
-                </a:solidFill>
-              </a:defRPr>
-            </a:pPr>
-            <a:r>
-              <a:t>   alert tcp any any -&gt; $DST $PORT (msg:"CYBERSHIELD SYN Flood"; flags:S; threshold:count 100, seconds 2; sid:2000001;)</a:t>
-            </a:r>
-          </a:p>
-          <a:p>
-            <a:pPr>
-              <a:spcAft>
-                <a:spcPts val="400"/>
-              </a:spcAft>
-              <a:defRPr sz="1100">
-                <a:solidFill>
-                  <a:srgbClr val="F3F4F6"/>
-                </a:solidFill>
-              </a:defRPr>
-            </a:pPr>
-          </a:p>
-          <a:p>
-            <a:pPr>
-              <a:spcAft>
-                <a:spcPts val="400"/>
-              </a:spcAft>
-              <a:defRPr sz="1100">
-                <a:solidFill>
-                  <a:srgbClr val="F3F4F6"/>
-                </a:solidFill>
-              </a:defRPr>
-            </a:pPr>
-            <a:r>
-              <a:t>4. Snort 3 Network Rule:</a:t>
-            </a:r>
-          </a:p>
-          <a:p>
-            <a:pPr>
-              <a:spcAft>
-                <a:spcPts val="400"/>
-              </a:spcAft>
-              <a:defRPr sz="1100">
-                <a:solidFill>
-                  <a:srgbClr val="F3F4F6"/>
-                </a:solidFill>
-              </a:defRPr>
-            </a:pPr>
-            <a:r>
-              <a:t>   drop tcp any any -&gt; $DST $PORT (detection_filter:track by_dst, count 100, seconds 2; sid:3000001;)</a:t>
-            </a:r>
-          </a:p>
-          <a:p>
-            <a:pPr>
-              <a:spcAft>
-                <a:spcPts val="400"/>
-              </a:spcAft>
-              <a:defRPr sz="1100">
-                <a:solidFill>
-                  <a:srgbClr val="F3F4F6"/>
-                </a:solidFill>
-              </a:defRPr>
-            </a:pPr>
-          </a:p>
-          <a:p>
-            <a:pPr>
-              <a:spcAft>
-                <a:spcPts val="400"/>
-              </a:spcAft>
-              <a:defRPr sz="1100">
-                <a:solidFill>
-                  <a:srgbClr val="F3F4F6"/>
-                </a:solidFill>
-              </a:defRPr>
-            </a:pPr>
-            <a:r>
-              <a:t>5. pfSense / OPNsense CLI:</a:t>
-            </a:r>
-          </a:p>
-          <a:p>
-            <a:pPr>
-              <a:spcAft>
-                <a:spcPts val="400"/>
-              </a:spcAft>
-              <a:defRPr sz="1100">
-                <a:solidFill>
-                  <a:srgbClr val="F3F4F6"/>
-                </a:solidFill>
-              </a:defRPr>
-            </a:pPr>
-            <a:r>
-              <a:t>   pfsense-cli block host &lt;ATTACKER_IP&gt;</a:t>
+            <a:r>
+              <a:t>• Suricata / Snort IDS: alert tcp any any -&gt; $DST $PORT (msg:"CYBERSHIELD Flood"; sid:2000001;)</a:t>
             </a:r>
           </a:p>
         </p:txBody>
@@ -6730,7 +6224,7 @@
         <p:spPr>
           <a:xfrm>
             <a:off x="731520" y="365760"/>
-            <a:ext cx="4114800" cy="320040"/>
+            <a:ext cx="5029200" cy="292608"/>
           </a:xfrm>
           <a:prstGeom prst="rect">
             <a:avLst/>
@@ -6764,8 +6258,8 @@
         </p:nvSpPr>
         <p:spPr>
           <a:xfrm>
-            <a:off x="731520" y="640080"/>
-            <a:ext cx="10698480" cy="548640"/>
+            <a:off x="731520" y="621792"/>
+            <a:ext cx="10698480" cy="502920"/>
           </a:xfrm>
           <a:prstGeom prst="rect">
             <a:avLst/>
@@ -6779,7 +6273,7 @@
           <a:lstStyle/>
           <a:p>
             <a:pPr>
-              <a:defRPr sz="2200" b="1">
+              <a:defRPr sz="2100" b="1">
                 <a:solidFill>
                   <a:srgbClr val="F3F4F6"/>
                 </a:solidFill>
@@ -6799,8 +6293,8 @@
         </p:nvSpPr>
         <p:spPr>
           <a:xfrm>
-            <a:off x="731520" y="1143000"/>
-            <a:ext cx="10698480" cy="365760"/>
+            <a:off x="731520" y="1097280"/>
+            <a:ext cx="10698480" cy="320040"/>
           </a:xfrm>
           <a:prstGeom prst="rect">
             <a:avLst/>
@@ -6814,7 +6308,7 @@
           <a:lstStyle/>
           <a:p>
             <a:pPr>
-              <a:defRPr sz="1200">
+              <a:defRPr sz="1150">
                 <a:solidFill>
                   <a:srgbClr val="9CA3AF"/>
                 </a:solidFill>
@@ -6834,8 +6328,112 @@
         </p:nvSpPr>
         <p:spPr>
           <a:xfrm>
-            <a:off x="731520" y="1645920"/>
-            <a:ext cx="5230368" cy="2331720"/>
+            <a:off x="731520" y="1508760"/>
+            <a:ext cx="6035040" cy="4983480"/>
+          </a:xfrm>
+          <a:prstGeom prst="roundRect">
+            <a:avLst/>
+          </a:prstGeom>
+          <a:solidFill>
+            <a:srgbClr val="111827"/>
+          </a:solidFill>
+          <a:ln w="15240">
+            <a:solidFill>
+              <a:srgbClr val="00E5FF"/>
+            </a:solidFill>
+          </a:ln>
+        </p:spPr>
+        <p:style>
+          <a:lnRef idx="1">
+            <a:schemeClr val="accent1"/>
+          </a:lnRef>
+          <a:fillRef idx="3">
+            <a:schemeClr val="accent1"/>
+          </a:fillRef>
+          <a:effectRef idx="2">
+            <a:schemeClr val="accent1"/>
+          </a:effectRef>
+          <a:fontRef idx="minor">
+            <a:schemeClr val="lt1"/>
+          </a:fontRef>
+        </p:style>
+        <p:txBody>
+          <a:bodyPr rtlCol="0" anchor="ctr"/>
+          <a:lstStyle/>
+          <a:p>
+            <a:pPr algn="ctr"/>
+          </a:p>
+        </p:txBody>
+      </p:sp>
+      <p:pic>
+        <p:nvPicPr>
+          <p:cNvPr id="6" name="Picture 5" descr="soc_dashboard_live.png"/>
+          <p:cNvPicPr>
+            <a:picLocks noChangeAspect="1"/>
+          </p:cNvPicPr>
+          <p:nvPr/>
+        </p:nvPicPr>
+        <p:blipFill>
+          <a:blip r:embed="rId2"/>
+          <a:stretch>
+            <a:fillRect/>
+          </a:stretch>
+        </p:blipFill>
+        <p:spPr>
+          <a:xfrm>
+            <a:off x="804672" y="1581912"/>
+            <a:ext cx="5888736" cy="4663440"/>
+          </a:xfrm>
+          <a:prstGeom prst="rect">
+            <a:avLst/>
+          </a:prstGeom>
+        </p:spPr>
+      </p:pic>
+      <p:sp>
+        <p:nvSpPr>
+          <p:cNvPr id="7" name="TextBox 6"/>
+          <p:cNvSpPr txBox="1"/>
+          <p:nvPr/>
+        </p:nvSpPr>
+        <p:spPr>
+          <a:xfrm>
+            <a:off x="731520" y="6199632"/>
+            <a:ext cx="6035040" cy="274320"/>
+          </a:xfrm>
+          <a:prstGeom prst="rect">
+            <a:avLst/>
+          </a:prstGeom>
+          <a:noFill/>
+        </p:spPr>
+        <p:txBody>
+          <a:bodyPr wrap="none">
+            <a:spAutoFit/>
+          </a:bodyPr>
+          <a:lstStyle/>
+          <a:p>
+            <a:pPr algn="ctr">
+              <a:defRPr sz="850" b="1">
+                <a:solidFill>
+                  <a:srgbClr val="00E5FF"/>
+                </a:solidFill>
+              </a:defRPr>
+            </a:pPr>
+            <a:r>
+              <a:t>LIVE OPERATIONS CONSOLE: OPTICAL THREAT RADAR, INGEST METRICS &amp; AUTHENTIC STREAM</a:t>
+            </a:r>
+          </a:p>
+        </p:txBody>
+      </p:sp>
+      <p:sp>
+        <p:nvSpPr>
+          <p:cNvPr id="8" name="Rounded Rectangle 7"/>
+          <p:cNvSpPr/>
+          <p:nvPr/>
+        </p:nvSpPr>
+        <p:spPr>
+          <a:xfrm>
+            <a:off x="6949440" y="1508760"/>
+            <a:ext cx="4507992" cy="1554480"/>
           </a:xfrm>
           <a:prstGeom prst="roundRect">
             <a:avLst/>
@@ -6873,14 +6471,14 @@
       </p:sp>
       <p:sp>
         <p:nvSpPr>
-          <p:cNvPr id="6" name="TextBox 5"/>
+          <p:cNvPr id="9" name="TextBox 8"/>
           <p:cNvSpPr txBox="1"/>
           <p:nvPr/>
         </p:nvSpPr>
         <p:spPr>
           <a:xfrm>
-            <a:off x="868680" y="1755648"/>
-            <a:ext cx="4956048" cy="2112264"/>
+            <a:off x="7077456" y="1600200"/>
+            <a:ext cx="4251960" cy="1371600"/>
           </a:xfrm>
           <a:prstGeom prst="rect">
             <a:avLst/>
@@ -6895,90 +6493,75 @@
           <a:p>
             <a:pPr>
               <a:spcAft>
-                <a:spcPts val="600"/>
-              </a:spcAft>
-              <a:defRPr sz="1400" b="1">
-                <a:solidFill>
-                  <a:srgbClr val="00E5FF"/>
-                </a:solidFill>
-              </a:defRPr>
-            </a:pPr>
-            <a:r>
-              <a:t>ENTERPRISE WEB SOC CONSOLE</a:t>
-            </a:r>
-          </a:p>
-          <a:p>
-            <a:pPr>
-              <a:spcAft>
                 <a:spcPts val="400"/>
               </a:spcAft>
-              <a:defRPr sz="1100">
+              <a:defRPr sz="1300" b="1">
+                <a:solidFill>
+                  <a:srgbClr val="10B981"/>
+                </a:solidFill>
+              </a:defRPr>
+            </a:pPr>
+            <a:r>
+              <a:t>GLOBAL HTTPS CLOUDFLARE TUNNEL</a:t>
+            </a:r>
+          </a:p>
+          <a:p>
+            <a:pPr>
+              <a:spcAft>
+                <a:spcPts val="300"/>
+              </a:spcAft>
+              <a:defRPr sz="1000">
                 <a:solidFill>
                   <a:srgbClr val="F3F4F6"/>
                 </a:solidFill>
               </a:defRPr>
             </a:pPr>
             <a:r>
-              <a:t>• Authentic Cyber Atmosphere: Dark obsidian UI, glassmorphic panels, and DEFCON status badge.</a:t>
+              <a:t>• Live Worldwide Link: https://red-avi-object-email.trycloudflare.com</a:t>
             </a:r>
           </a:p>
           <a:p>
             <a:pPr>
               <a:spcAft>
-                <a:spcPts val="400"/>
+                <a:spcPts val="300"/>
               </a:spcAft>
-              <a:defRPr sz="1100">
+              <a:defRPr sz="1000">
                 <a:solidFill>
                   <a:srgbClr val="F3F4F6"/>
                 </a:solidFill>
               </a:defRPr>
             </a:pPr>
             <a:r>
-              <a:t>• Non-Uniform Time Interleaving: Millisecond jitter timestamps break artificial looping patterns.</a:t>
+              <a:t>• Zero-Barrier Access: No firewall port forwarding or public IP exposure.</a:t>
             </a:r>
           </a:p>
           <a:p>
             <a:pPr>
               <a:spcAft>
-                <a:spcPts val="400"/>
+                <a:spcPts val="300"/>
               </a:spcAft>
-              <a:defRPr sz="1100">
+              <a:defRPr sz="1000">
                 <a:solidFill>
                   <a:srgbClr val="F3F4F6"/>
                 </a:solidFill>
               </a:defRPr>
             </a:pPr>
             <a:r>
-              <a:t>• Corporate Asset Attribution: Maps raw IPs to enterprise DNS hostnames (wkst-*.corp, ad-dc01.corp).</a:t>
-            </a:r>
-          </a:p>
-          <a:p>
-            <a:pPr>
-              <a:spcAft>
-                <a:spcPts val="400"/>
-              </a:spcAft>
-              <a:defRPr sz="1100">
-                <a:solidFill>
-                  <a:srgbClr val="F3F4F6"/>
-                </a:solidFill>
-              </a:defRPr>
-            </a:pPr>
-            <a:r>
-              <a:t>• Real-Time Threat Radar: SVG canvas visualizing live network ingress and fanout connections.</a:t>
-            </a:r>
-          </a:p>
-        </p:txBody>
-      </p:sp>
-      <p:sp>
-        <p:nvSpPr>
-          <p:cNvPr id="7" name="Rounded Rectangle 6"/>
+              <a:t>• Interactive Threat Injection: Trigger live SYN floods &amp; C2 beacon pulses.</a:t>
+            </a:r>
+          </a:p>
+        </p:txBody>
+      </p:sp>
+      <p:sp>
+        <p:nvSpPr>
+          <p:cNvPr id="10" name="Rounded Rectangle 9"/>
           <p:cNvSpPr/>
           <p:nvPr/>
         </p:nvSpPr>
         <p:spPr>
           <a:xfrm>
-            <a:off x="6217920" y="1645920"/>
-            <a:ext cx="5230368" cy="2331720"/>
+            <a:off x="6949440" y="3200400"/>
+            <a:ext cx="4507992" cy="1554480"/>
           </a:xfrm>
           <a:prstGeom prst="roundRect">
             <a:avLst/>
@@ -7016,14 +6599,14 @@
       </p:sp>
       <p:sp>
         <p:nvSpPr>
-          <p:cNvPr id="8" name="TextBox 7"/>
+          <p:cNvPr id="11" name="TextBox 10"/>
           <p:cNvSpPr txBox="1"/>
           <p:nvPr/>
         </p:nvSpPr>
         <p:spPr>
           <a:xfrm>
-            <a:off x="6355080" y="1755648"/>
-            <a:ext cx="4956048" cy="2112264"/>
+            <a:off x="7077456" y="3291840"/>
+            <a:ext cx="4251960" cy="1371600"/>
           </a:xfrm>
           <a:prstGeom prst="rect">
             <a:avLst/>
@@ -7038,90 +6621,75 @@
           <a:p>
             <a:pPr>
               <a:spcAft>
-                <a:spcPts val="600"/>
-              </a:spcAft>
-              <a:defRPr sz="1400" b="1">
-                <a:solidFill>
-                  <a:srgbClr val="10B981"/>
-                </a:solidFill>
-              </a:defRPr>
-            </a:pPr>
-            <a:r>
-              <a:t>GLOBAL HTTPS CLOUDFLARE TUNNEL</a:t>
-            </a:r>
-          </a:p>
-          <a:p>
-            <a:pPr>
-              <a:spcAft>
                 <a:spcPts val="400"/>
               </a:spcAft>
-              <a:defRPr sz="1100">
+              <a:defRPr sz="1300" b="1">
+                <a:solidFill>
+                  <a:srgbClr val="3B82F6"/>
+                </a:solidFill>
+              </a:defRPr>
+            </a:pPr>
+            <a:r>
+              <a:t>PERMANENT EDGE WEB (GITHUB PAGES)</a:t>
+            </a:r>
+          </a:p>
+          <a:p>
+            <a:pPr>
+              <a:spcAft>
+                <a:spcPts val="300"/>
+              </a:spcAft>
+              <a:defRPr sz="1000">
                 <a:solidFill>
                   <a:srgbClr val="F3F4F6"/>
                 </a:solidFill>
               </a:defRPr>
             </a:pPr>
             <a:r>
-              <a:t>• Worldwide Live URL: https://red-avi-object-email.trycloudflare.com</a:t>
+              <a:t>• Permanent 24/7 Hosting: https://saicharan-nayak.github.io/unidirectional-threat-engine/</a:t>
             </a:r>
           </a:p>
           <a:p>
             <a:pPr>
               <a:spcAft>
-                <a:spcPts val="400"/>
+                <a:spcPts val="300"/>
               </a:spcAft>
-              <a:defRPr sz="1100">
+              <a:defRPr sz="1000">
                 <a:solidFill>
                   <a:srgbClr val="F3F4F6"/>
                 </a:solidFill>
               </a:defRPr>
             </a:pPr>
             <a:r>
-              <a:t>• Zero-Barrier Access: No firewall port forwarding or public IP exposure required.</a:t>
+              <a:t>• Autonomous Dual-Mode: Seamless WebSocket or client simulation fallback.</a:t>
             </a:r>
           </a:p>
           <a:p>
             <a:pPr>
               <a:spcAft>
-                <a:spcPts val="400"/>
+                <a:spcPts val="300"/>
               </a:spcAft>
-              <a:defRPr sz="1100">
+              <a:defRPr sz="1000">
                 <a:solidFill>
                   <a:srgbClr val="F3F4F6"/>
                 </a:solidFill>
               </a:defRPr>
             </a:pPr>
             <a:r>
-              <a:t>• Real-Time Bi-Directional WebSocket: Sub-millisecond telemetry stream direct to any device.</a:t>
-            </a:r>
-          </a:p>
-          <a:p>
-            <a:pPr>
-              <a:spcAft>
-                <a:spcPts val="400"/>
-              </a:spcAft>
-              <a:defRPr sz="1100">
-                <a:solidFill>
-                  <a:srgbClr val="F3F4F6"/>
-                </a:solidFill>
-              </a:defRPr>
-            </a:pPr>
-            <a:r>
-              <a:t>• Interactive Threat Injection: Trigger live SYN floods, C2 beacon pulses, and port recon scans.</a:t>
-            </a:r>
-          </a:p>
-        </p:txBody>
-      </p:sp>
-      <p:sp>
-        <p:nvSpPr>
-          <p:cNvPr id="9" name="Rounded Rectangle 8"/>
+              <a:t>• Automated CI/CD: Deployed automatically via GitHub Actions on push.</a:t>
+            </a:r>
+          </a:p>
+        </p:txBody>
+      </p:sp>
+      <p:sp>
+        <p:nvSpPr>
+          <p:cNvPr id="12" name="Rounded Rectangle 11"/>
           <p:cNvSpPr/>
           <p:nvPr/>
         </p:nvSpPr>
         <p:spPr>
           <a:xfrm>
-            <a:off x="731520" y="4160520"/>
-            <a:ext cx="5230368" cy="2331720"/>
+            <a:off x="6949440" y="4892040"/>
+            <a:ext cx="4507992" cy="1600200"/>
           </a:xfrm>
           <a:prstGeom prst="roundRect">
             <a:avLst/>
@@ -7159,14 +6727,14 @@
       </p:sp>
       <p:sp>
         <p:nvSpPr>
-          <p:cNvPr id="10" name="TextBox 9"/>
+          <p:cNvPr id="13" name="TextBox 12"/>
           <p:cNvSpPr txBox="1"/>
           <p:nvPr/>
         </p:nvSpPr>
         <p:spPr>
           <a:xfrm>
-            <a:off x="868680" y="4270248"/>
-            <a:ext cx="4956048" cy="2112264"/>
+            <a:off x="7077456" y="4983480"/>
+            <a:ext cx="4251960" cy="1417320"/>
           </a:xfrm>
           <a:prstGeom prst="rect">
             <a:avLst/>
@@ -7181,219 +6749,61 @@
           <a:p>
             <a:pPr>
               <a:spcAft>
-                <a:spcPts val="600"/>
-              </a:spcAft>
-              <a:defRPr sz="1400" b="1">
-                <a:solidFill>
-                  <a:srgbClr val="3B82F6"/>
-                </a:solidFill>
-              </a:defRPr>
-            </a:pPr>
-            <a:r>
-              <a:t>PERMANENT EDGE WEB (GITHUB PAGES)</a:t>
-            </a:r>
-          </a:p>
-          <a:p>
-            <a:pPr>
-              <a:spcAft>
                 <a:spcPts val="400"/>
               </a:spcAft>
-              <a:defRPr sz="1100">
+              <a:defRPr sz="1300" b="1">
+                <a:solidFill>
+                  <a:srgbClr val="F59E0B"/>
+                </a:solidFill>
+              </a:defRPr>
+            </a:pPr>
+            <a:r>
+              <a:t>ANDROID STUDIO APP &amp; SIEM</a:t>
+            </a:r>
+          </a:p>
+          <a:p>
+            <a:pPr>
+              <a:spcAft>
+                <a:spcPts val="300"/>
+              </a:spcAft>
+              <a:defRPr sz="1000">
                 <a:solidFill>
                   <a:srgbClr val="F3F4F6"/>
                 </a:solidFill>
               </a:defRPr>
             </a:pPr>
             <a:r>
-              <a:t>• Permanent 24/7 Hosting: https://saicharan-nayak.github.io/unidirectional-threat-engine/</a:t>
+              <a:t>• Native Android App: android_studio_app/ WebView wrapper with touch HUD.</a:t>
             </a:r>
           </a:p>
           <a:p>
             <a:pPr>
               <a:spcAft>
-                <a:spcPts val="400"/>
+                <a:spcPts val="300"/>
               </a:spcAft>
-              <a:defRPr sz="1100">
+              <a:defRPr sz="1000">
                 <a:solidFill>
                   <a:srgbClr val="F3F4F6"/>
                 </a:solidFill>
               </a:defRPr>
             </a:pPr>
             <a:r>
-              <a:t>• Autonomous Dual-Mode: Automatically connects to live backend WebSocket if online.</a:t>
+              <a:t>• One-Click Launcher: Open_In_Android_Studio.bat auto-detects active IDE.</a:t>
             </a:r>
           </a:p>
           <a:p>
             <a:pPr>
               <a:spcAft>
-                <a:spcPts val="400"/>
+                <a:spcPts val="300"/>
               </a:spcAft>
-              <a:defRPr sz="1100">
+              <a:defRPr sz="1000">
                 <a:solidFill>
                   <a:srgbClr val="F3F4F6"/>
                 </a:solidFill>
               </a:defRPr>
             </a:pPr>
             <a:r>
-              <a:t>• Zero-Server Fallback: Auto-engages high-fidelity client-side simulation engine if offline.</a:t>
-            </a:r>
-          </a:p>
-          <a:p>
-            <a:pPr>
-              <a:spcAft>
-                <a:spcPts val="400"/>
-              </a:spcAft>
-              <a:defRPr sz="1100">
-                <a:solidFill>
-                  <a:srgbClr val="F3F4F6"/>
-                </a:solidFill>
-              </a:defRPr>
-            </a:pPr>
-            <a:r>
-              <a:t>• Automated CI/CD: Deployed automatically via .github/workflows/deploy-pages.yml on push.</a:t>
-            </a:r>
-          </a:p>
-        </p:txBody>
-      </p:sp>
-      <p:sp>
-        <p:nvSpPr>
-          <p:cNvPr id="11" name="Rounded Rectangle 10"/>
-          <p:cNvSpPr/>
-          <p:nvPr/>
-        </p:nvSpPr>
-        <p:spPr>
-          <a:xfrm>
-            <a:off x="6217920" y="4160520"/>
-            <a:ext cx="5230368" cy="2331720"/>
-          </a:xfrm>
-          <a:prstGeom prst="roundRect">
-            <a:avLst/>
-          </a:prstGeom>
-          <a:solidFill>
-            <a:srgbClr val="172135"/>
-          </a:solidFill>
-          <a:ln w="15240">
-            <a:solidFill>
-              <a:srgbClr val="25324E"/>
-            </a:solidFill>
-          </a:ln>
-        </p:spPr>
-        <p:style>
-          <a:lnRef idx="1">
-            <a:schemeClr val="accent1"/>
-          </a:lnRef>
-          <a:fillRef idx="3">
-            <a:schemeClr val="accent1"/>
-          </a:fillRef>
-          <a:effectRef idx="2">
-            <a:schemeClr val="accent1"/>
-          </a:effectRef>
-          <a:fontRef idx="minor">
-            <a:schemeClr val="lt1"/>
-          </a:fontRef>
-        </p:style>
-        <p:txBody>
-          <a:bodyPr rtlCol="0" anchor="ctr"/>
-          <a:lstStyle/>
-          <a:p>
-            <a:pPr algn="ctr"/>
-          </a:p>
-        </p:txBody>
-      </p:sp>
-      <p:sp>
-        <p:nvSpPr>
-          <p:cNvPr id="12" name="TextBox 11"/>
-          <p:cNvSpPr txBox="1"/>
-          <p:nvPr/>
-        </p:nvSpPr>
-        <p:spPr>
-          <a:xfrm>
-            <a:off x="6355080" y="4270248"/>
-            <a:ext cx="4956048" cy="2112264"/>
-          </a:xfrm>
-          <a:prstGeom prst="rect">
-            <a:avLst/>
-          </a:prstGeom>
-          <a:noFill/>
-        </p:spPr>
-        <p:txBody>
-          <a:bodyPr wrap="square">
-            <a:spAutoFit/>
-          </a:bodyPr>
-          <a:lstStyle/>
-          <a:p>
-            <a:pPr>
-              <a:spcAft>
-                <a:spcPts val="600"/>
-              </a:spcAft>
-              <a:defRPr sz="1400" b="1">
-                <a:solidFill>
-                  <a:srgbClr val="F59E0B"/>
-                </a:solidFill>
-              </a:defRPr>
-            </a:pPr>
-            <a:r>
-              <a:t>ANDROID STUDIO NATIVE APP &amp; REPO</a:t>
-            </a:r>
-          </a:p>
-          <a:p>
-            <a:pPr>
-              <a:spcAft>
-                <a:spcPts val="400"/>
-              </a:spcAft>
-              <a:defRPr sz="1100">
-                <a:solidFill>
-                  <a:srgbClr val="F3F4F6"/>
-                </a:solidFill>
-              </a:defRPr>
-            </a:pPr>
-            <a:r>
-              <a:t>• Android Studio Project: android_studio_app/ native WebView wrapper with full touch controls.</a:t>
-            </a:r>
-          </a:p>
-          <a:p>
-            <a:pPr>
-              <a:spcAft>
-                <a:spcPts val="400"/>
-              </a:spcAft>
-              <a:defRPr sz="1100">
-                <a:solidFill>
-                  <a:srgbClr val="F3F4F6"/>
-                </a:solidFill>
-              </a:defRPr>
-            </a:pPr>
-            <a:r>
-              <a:t>• One-Click Launcher: Open_In_Android_Studio.bat auto-detects active Android Studio executable.</a:t>
-            </a:r>
-          </a:p>
-          <a:p>
-            <a:pPr>
-              <a:spcAft>
-                <a:spcPts val="400"/>
-              </a:spcAft>
-              <a:defRPr sz="1100">
-                <a:solidFill>
-                  <a:srgbClr val="F3F4F6"/>
-                </a:solidFill>
-              </a:defRPr>
-            </a:pPr>
-            <a:r>
-              <a:t>• SIEM Integrations: Background worker exporting ArcSight CEF, RFC 5424 Syslog, and Webhooks.</a:t>
-            </a:r>
-          </a:p>
-          <a:p>
-            <a:pPr>
-              <a:spcAft>
-                <a:spcPts val="400"/>
-              </a:spcAft>
-              <a:defRPr sz="1100">
-                <a:solidFill>
-                  <a:srgbClr val="F3F4F6"/>
-                </a:solidFill>
-              </a:defRPr>
-            </a:pPr>
-            <a:r>
-              <a:t>• Open Source GitHub Repo: SAICHARAN-NAYAK/unidirectional-threat-engine (main branch).</a:t>
+              <a:t>• SIEM Integrations: Background worker exporting ArcSight CEF and Syslog.</a:t>
             </a:r>
           </a:p>
         </p:txBody>

</xml_diff>